<commit_message>
Switch to earthy green/brown/red palette and refine assignment content
Replace the plum/gold/magenta palette with an earthy, ethereal theme
built from forest green, umber brown, and rust red across both light
and dark mode. Also move Syllabus & Resources to the second tab,
restructure the four assignment tasks with subheadings and bullets
matching the original slide wording, drop "Final" from the grading
table, and trim the downloadable example deck to just the case study
(slides 9-17), updating its download caption to match.

Co-Authored-By: Claude Sonnet 5 <noreply@anthropic.com>
</commit_message>
<xml_diff>
--- a/assets/files/Being-Seen-Example-Presentation.pptx
+++ b/assets/files/Being-Seen-Example-Presentation.pptx
@@ -11,14 +11,6 @@
     <p:handoutMasterId r:id="rId23"/>
   </p:handoutMasterIdLst>
   <p:sldIdLst>
-    <p:sldId id="1497" r:id="rId5"/>
-    <p:sldId id="1524" r:id="rId6"/>
-    <p:sldId id="1518" r:id="rId7"/>
-    <p:sldId id="1519" r:id="rId8"/>
-    <p:sldId id="1498" r:id="rId9"/>
-    <p:sldId id="1514" r:id="rId10"/>
-    <p:sldId id="1515" r:id="rId11"/>
-    <p:sldId id="1516" r:id="rId12"/>
     <p:sldId id="1499" r:id="rId13"/>
     <p:sldId id="1503" r:id="rId14"/>
     <p:sldId id="1523" r:id="rId15"/>
@@ -18071,119 +18063,6 @@
 </p:sldMaster>
 </file>
 
-<file path=ppt/slides/slide1.xml><?xml version="1.0" encoding="utf-8"?>
-<p:sld xmlns:a="http://schemas.openxmlformats.org/drawingml/2006/main" xmlns:r="http://schemas.openxmlformats.org/officeDocument/2006/relationships" xmlns:p="http://schemas.openxmlformats.org/presentationml/2006/main">
-  <p:cSld>
-    <p:spTree>
-      <p:nvGrpSpPr>
-        <p:cNvPr id="1" name=""/>
-        <p:cNvGrpSpPr/>
-        <p:nvPr/>
-      </p:nvGrpSpPr>
-      <p:grpSpPr>
-        <a:xfrm>
-          <a:off x="0" y="0"/>
-          <a:ext cx="0" cy="0"/>
-          <a:chOff x="0" y="0"/>
-          <a:chExt cx="0" cy="0"/>
-        </a:xfrm>
-      </p:grpSpPr>
-      <p:sp>
-        <p:nvSpPr>
-          <p:cNvPr id="2" name="Title 1">
-            <a:extLst>
-              <a:ext uri="{FF2B5EF4-FFF2-40B4-BE49-F238E27FC236}">
-                <a16:creationId xmlns:a16="http://schemas.microsoft.com/office/drawing/2014/main" id="{1F057989-07E4-B482-9F2A-EBF670F7FA92}"/>
-              </a:ext>
-            </a:extLst>
-          </p:cNvPr>
-          <p:cNvSpPr>
-            <a:spLocks noGrp="1"/>
-          </p:cNvSpPr>
-          <p:nvPr>
-            <p:ph type="ctrTitle"/>
-          </p:nvPr>
-        </p:nvSpPr>
-        <p:spPr>
-          <a:xfrm>
-            <a:off x="1154954" y="1447800"/>
-            <a:ext cx="9444621" cy="3329581"/>
-          </a:xfrm>
-        </p:spPr>
-        <p:txBody>
-          <a:bodyPr/>
-          <a:lstStyle/>
-          <a:p>
-            <a:r>
-              <a:rPr lang="en-US" sz="6600" dirty="0"/>
-              <a:t>Signature Assignment-</a:t>
-            </a:r>
-            <a:br>
-              <a:rPr lang="en-US" sz="6600" dirty="0"/>
-            </a:br>
-            <a:r>
-              <a:rPr lang="en-US" sz="6000" dirty="0"/>
-              <a:t>Being Seen-The Presentation</a:t>
-            </a:r>
-            <a:endParaRPr lang="en-US" sz="6600" dirty="0"/>
-          </a:p>
-        </p:txBody>
-      </p:sp>
-      <p:sp>
-        <p:nvSpPr>
-          <p:cNvPr id="3" name="Subtitle 2">
-            <a:extLst>
-              <a:ext uri="{FF2B5EF4-FFF2-40B4-BE49-F238E27FC236}">
-                <a16:creationId xmlns:a16="http://schemas.microsoft.com/office/drawing/2014/main" id="{363CF5F8-0028-8636-5006-5D5C52B32774}"/>
-              </a:ext>
-            </a:extLst>
-          </p:cNvPr>
-          <p:cNvSpPr>
-            <a:spLocks noGrp="1"/>
-          </p:cNvSpPr>
-          <p:nvPr>
-            <p:ph type="subTitle" idx="1"/>
-          </p:nvPr>
-        </p:nvSpPr>
-        <p:spPr/>
-        <p:txBody>
-          <a:bodyPr>
-            <a:normAutofit fontScale="70000" lnSpcReduction="20000"/>
-          </a:bodyPr>
-          <a:lstStyle/>
-          <a:p>
-            <a:r>
-              <a:rPr lang="en-US" dirty="0"/>
-              <a:t>Nyree Brown</a:t>
-            </a:r>
-          </a:p>
-          <a:p>
-            <a:r>
-              <a:rPr lang="en-US" dirty="0"/>
-              <a:t>July 5, 2026</a:t>
-            </a:r>
-          </a:p>
-          <a:p>
-            <a:r>
-              <a:rPr lang="en-US" dirty="0"/>
-              <a:t>ENG 6813. SU26</a:t>
-            </a:r>
-          </a:p>
-        </p:txBody>
-      </p:sp>
-    </p:spTree>
-    <p:extLst>
-      <p:ext uri="{BB962C8B-B14F-4D97-AF65-F5344CB8AC3E}">
-        <p14:creationId xmlns:p14="http://schemas.microsoft.com/office/powerpoint/2010/main" val="1773831372"/>
-      </p:ext>
-    </p:extLst>
-  </p:cSld>
-  <p:clrMapOvr>
-    <a:masterClrMapping/>
-  </p:clrMapOvr>
-</p:sld>
-</file>
-
 <file path=ppt/slides/slide10.xml><?xml version="1.0" encoding="utf-8"?>
 <p:sld xmlns:a="http://schemas.openxmlformats.org/drawingml/2006/main" xmlns:r="http://schemas.openxmlformats.org/officeDocument/2006/relationships" xmlns:p="http://schemas.openxmlformats.org/presentationml/2006/main">
   <p:cSld>
@@ -21997,2456 +21876,6 @@
     <p:extLst>
       <p:ext uri="{BB962C8B-B14F-4D97-AF65-F5344CB8AC3E}">
         <p14:creationId xmlns:p14="http://schemas.microsoft.com/office/powerpoint/2010/main" val="2236553916"/>
-      </p:ext>
-    </p:extLst>
-  </p:cSld>
-  <p:clrMapOvr>
-    <a:masterClrMapping/>
-  </p:clrMapOvr>
-</p:sld>
-</file>
-
-<file path=ppt/slides/slide2.xml><?xml version="1.0" encoding="utf-8"?>
-<p:sld xmlns:a="http://schemas.openxmlformats.org/drawingml/2006/main" xmlns:r="http://schemas.openxmlformats.org/officeDocument/2006/relationships" xmlns:p="http://schemas.openxmlformats.org/presentationml/2006/main">
-  <p:cSld>
-    <p:spTree>
-      <p:nvGrpSpPr>
-        <p:cNvPr id="1" name=""/>
-        <p:cNvGrpSpPr/>
-        <p:nvPr/>
-      </p:nvGrpSpPr>
-      <p:grpSpPr>
-        <a:xfrm>
-          <a:off x="0" y="0"/>
-          <a:ext cx="0" cy="0"/>
-          <a:chOff x="0" y="0"/>
-          <a:chExt cx="0" cy="0"/>
-        </a:xfrm>
-      </p:grpSpPr>
-      <p:sp>
-        <p:nvSpPr>
-          <p:cNvPr id="2" name="Title 1">
-            <a:extLst>
-              <a:ext uri="{FF2B5EF4-FFF2-40B4-BE49-F238E27FC236}">
-                <a16:creationId xmlns:a16="http://schemas.microsoft.com/office/drawing/2014/main" id="{F1052758-8E91-A63A-19BF-5F4F47199D0B}"/>
-              </a:ext>
-            </a:extLst>
-          </p:cNvPr>
-          <p:cNvSpPr>
-            <a:spLocks noGrp="1"/>
-          </p:cNvSpPr>
-          <p:nvPr>
-            <p:ph type="title"/>
-          </p:nvPr>
-        </p:nvSpPr>
-        <p:spPr/>
-        <p:txBody>
-          <a:bodyPr/>
-          <a:lstStyle/>
-          <a:p>
-            <a:r>
-              <a:rPr lang="en-US" dirty="0"/>
-              <a:t>Course Context Changes</a:t>
-            </a:r>
-          </a:p>
-        </p:txBody>
-      </p:sp>
-      <p:sp>
-        <p:nvSpPr>
-          <p:cNvPr id="3" name="Content Placeholder 2">
-            <a:extLst>
-              <a:ext uri="{FF2B5EF4-FFF2-40B4-BE49-F238E27FC236}">
-                <a16:creationId xmlns:a16="http://schemas.microsoft.com/office/drawing/2014/main" id="{6FECB541-4D71-F004-E96F-2735D64FAC45}"/>
-              </a:ext>
-            </a:extLst>
-          </p:cNvPr>
-          <p:cNvSpPr>
-            <a:spLocks noGrp="1"/>
-          </p:cNvSpPr>
-          <p:nvPr>
-            <p:ph idx="1"/>
-          </p:nvPr>
-        </p:nvSpPr>
-        <p:spPr>
-          <a:xfrm>
-            <a:off x="569167" y="1110343"/>
-            <a:ext cx="10832841" cy="5365102"/>
-          </a:xfrm>
-        </p:spPr>
-        <p:txBody>
-          <a:bodyPr>
-            <a:normAutofit lnSpcReduction="10000"/>
-          </a:bodyPr>
-          <a:lstStyle/>
-          <a:p>
-            <a:r>
-              <a:rPr lang="en-US" dirty="0"/>
-              <a:t>Numerous Items have changed in my vision for this course.</a:t>
-            </a:r>
-          </a:p>
-          <a:p>
-            <a:pPr lvl="1"/>
-            <a:r>
-              <a:rPr lang="en-US" dirty="0"/>
-              <a:t>Starting with the theme of the course “Analyzing literature, film, visual art, and music in a social/historical context to examine examples of black women in love: familiar, romantic, and community-based platonic love. ” as of May 24</a:t>
-            </a:r>
-            <a:r>
-              <a:rPr lang="en-US" baseline="30000" dirty="0"/>
-              <a:t>th </a:t>
-            </a:r>
-            <a:r>
-              <a:rPr lang="en-US" dirty="0"/>
-              <a:t>2026</a:t>
-            </a:r>
-          </a:p>
-          <a:p>
-            <a:pPr lvl="2"/>
-            <a:r>
-              <a:rPr lang="en-US" dirty="0"/>
-              <a:t>I have a clearer focus and overall course goal that has a connection to what the student needs are outside of the classroom.  A major change is not focusing on love as the only lens, broadening students' ability to think critically, and not guiding them to a single viewpoint.</a:t>
-            </a:r>
-          </a:p>
-          <a:p>
-            <a:pPr lvl="1"/>
-            <a:r>
-              <a:rPr lang="en-US" dirty="0"/>
-              <a:t>Course name Change: “Viewing the Black Women”</a:t>
-            </a:r>
-          </a:p>
-          <a:p>
-            <a:pPr lvl="1"/>
-            <a:r>
-              <a:rPr lang="en-US" dirty="0"/>
-              <a:t>Instead of being housed under the humanities, it would align with an African Diaspora studies department.</a:t>
-            </a:r>
-          </a:p>
-          <a:p>
-            <a:pPr lvl="1"/>
-            <a:r>
-              <a:rPr lang="en-US" dirty="0"/>
-              <a:t>For this signature assignment, I started with the student goals, which anchor the assignment, utilizing backward design.</a:t>
-            </a:r>
-          </a:p>
-          <a:p>
-            <a:pPr lvl="1"/>
-            <a:r>
-              <a:rPr lang="en-US" dirty="0">
-                <a:solidFill>
-                  <a:srgbClr val="FFFFFF"/>
-                </a:solidFill>
-              </a:rPr>
-              <a:t>Course design has more of an intent on scaffolding</a:t>
-            </a:r>
-          </a:p>
-          <a:p>
-            <a:pPr lvl="1"/>
-            <a:r>
-              <a:rPr lang="en-US" dirty="0"/>
-              <a:t> Modality change to be Mixed mode when originally designed based on online modality.</a:t>
-            </a:r>
-          </a:p>
-          <a:p>
-            <a:pPr lvl="1"/>
-            <a:r>
-              <a:rPr lang="en-US" dirty="0"/>
-              <a:t>Previously was a supporter of a No AI use policy, but I have changed my approach to integrate AI to be specific to the assignment given.</a:t>
-            </a:r>
-          </a:p>
-          <a:p>
-            <a:pPr lvl="1"/>
-            <a:endParaRPr lang="en-US" dirty="0"/>
-          </a:p>
-          <a:p>
-            <a:pPr lvl="1"/>
-            <a:endParaRPr lang="en-US" dirty="0"/>
-          </a:p>
-          <a:p>
-            <a:pPr lvl="1"/>
-            <a:endParaRPr lang="en-US" dirty="0"/>
-          </a:p>
-          <a:p>
-            <a:pPr lvl="1"/>
-            <a:endParaRPr lang="en-US" dirty="0"/>
-          </a:p>
-        </p:txBody>
-      </p:sp>
-    </p:spTree>
-    <p:extLst>
-      <p:ext uri="{BB962C8B-B14F-4D97-AF65-F5344CB8AC3E}">
-        <p14:creationId xmlns:p14="http://schemas.microsoft.com/office/powerpoint/2010/main" val="3276058531"/>
-      </p:ext>
-    </p:extLst>
-  </p:cSld>
-  <p:clrMapOvr>
-    <a:masterClrMapping/>
-  </p:clrMapOvr>
-</p:sld>
-</file>
-
-<file path=ppt/slides/slide3.xml><?xml version="1.0" encoding="utf-8"?>
-<p:sld xmlns:a="http://schemas.openxmlformats.org/drawingml/2006/main" xmlns:r="http://schemas.openxmlformats.org/officeDocument/2006/relationships" xmlns:p="http://schemas.openxmlformats.org/presentationml/2006/main">
-  <p:cSld>
-    <p:spTree>
-      <p:nvGrpSpPr>
-        <p:cNvPr id="1" name=""/>
-        <p:cNvGrpSpPr/>
-        <p:nvPr/>
-      </p:nvGrpSpPr>
-      <p:grpSpPr>
-        <a:xfrm>
-          <a:off x="0" y="0"/>
-          <a:ext cx="0" cy="0"/>
-          <a:chOff x="0" y="0"/>
-          <a:chExt cx="0" cy="0"/>
-        </a:xfrm>
-      </p:grpSpPr>
-      <p:sp>
-        <p:nvSpPr>
-          <p:cNvPr id="2" name="Title 1">
-            <a:extLst>
-              <a:ext uri="{FF2B5EF4-FFF2-40B4-BE49-F238E27FC236}">
-                <a16:creationId xmlns:a16="http://schemas.microsoft.com/office/drawing/2014/main" id="{CEA53691-1E29-F958-4516-21E9C6C6CB18}"/>
-              </a:ext>
-            </a:extLst>
-          </p:cNvPr>
-          <p:cNvSpPr>
-            <a:spLocks noGrp="1"/>
-          </p:cNvSpPr>
-          <p:nvPr>
-            <p:ph type="ctrTitle"/>
-          </p:nvPr>
-        </p:nvSpPr>
-        <p:spPr>
-          <a:xfrm>
-            <a:off x="987004" y="1219200"/>
-            <a:ext cx="8825658" cy="1483675"/>
-          </a:xfrm>
-        </p:spPr>
-        <p:txBody>
-          <a:bodyPr/>
-          <a:lstStyle/>
-          <a:p>
-            <a:r>
-              <a:rPr lang="en-US" dirty="0"/>
-              <a:t>Course Goal</a:t>
-            </a:r>
-            <a:br>
-              <a:rPr lang="en-US" dirty="0"/>
-            </a:br>
-            <a:r>
-              <a:rPr lang="en-US" sz="3200" dirty="0"/>
-              <a:t>Viewing the Black Women</a:t>
-            </a:r>
-            <a:endParaRPr lang="en-US" dirty="0"/>
-          </a:p>
-        </p:txBody>
-      </p:sp>
-      <p:sp>
-        <p:nvSpPr>
-          <p:cNvPr id="3" name="Subtitle 2">
-            <a:extLst>
-              <a:ext uri="{FF2B5EF4-FFF2-40B4-BE49-F238E27FC236}">
-                <a16:creationId xmlns:a16="http://schemas.microsoft.com/office/drawing/2014/main" id="{C381D02A-DEE6-74A5-CC43-203D9041654D}"/>
-              </a:ext>
-            </a:extLst>
-          </p:cNvPr>
-          <p:cNvSpPr>
-            <a:spLocks noGrp="1"/>
-          </p:cNvSpPr>
-          <p:nvPr>
-            <p:ph type="subTitle" idx="1"/>
-          </p:nvPr>
-        </p:nvSpPr>
-        <p:spPr>
-          <a:xfrm>
-            <a:off x="987004" y="3001400"/>
-            <a:ext cx="9332653" cy="2114886"/>
-          </a:xfrm>
-        </p:spPr>
-        <p:txBody>
-          <a:bodyPr>
-            <a:normAutofit fontScale="92500" lnSpcReduction="10000"/>
-          </a:bodyPr>
-          <a:lstStyle/>
-          <a:p>
-            <a:r>
-              <a:rPr lang="en-US" dirty="0">
-                <a:solidFill>
-                  <a:schemeClr val="tx1"/>
-                </a:solidFill>
-              </a:rPr>
-              <a:t>By the end of the semester, students will be able to construct and defend a research-supported argument about how Black women are portrayed in media (painting, text, film, photograph, song, etc.), citing credible sources to support their position. Students will build cultural awareness and compassion, which are needed to critically engage with representation and bias in the news, advertising, and entertainment media.</a:t>
-            </a:r>
-          </a:p>
-        </p:txBody>
-      </p:sp>
-    </p:spTree>
-    <p:extLst>
-      <p:ext uri="{BB962C8B-B14F-4D97-AF65-F5344CB8AC3E}">
-        <p14:creationId xmlns:p14="http://schemas.microsoft.com/office/powerpoint/2010/main" val="2032650364"/>
-      </p:ext>
-    </p:extLst>
-  </p:cSld>
-  <p:clrMapOvr>
-    <a:masterClrMapping/>
-  </p:clrMapOvr>
-</p:sld>
-</file>
-
-<file path=ppt/slides/slide4.xml><?xml version="1.0" encoding="utf-8"?>
-<p:sld xmlns:a="http://schemas.openxmlformats.org/drawingml/2006/main" xmlns:r="http://schemas.openxmlformats.org/officeDocument/2006/relationships" xmlns:p="http://schemas.openxmlformats.org/presentationml/2006/main">
-  <p:cSld>
-    <p:spTree>
-      <p:nvGrpSpPr>
-        <p:cNvPr id="1" name=""/>
-        <p:cNvGrpSpPr/>
-        <p:nvPr/>
-      </p:nvGrpSpPr>
-      <p:grpSpPr>
-        <a:xfrm>
-          <a:off x="0" y="0"/>
-          <a:ext cx="0" cy="0"/>
-          <a:chOff x="0" y="0"/>
-          <a:chExt cx="0" cy="0"/>
-        </a:xfrm>
-      </p:grpSpPr>
-      <p:sp>
-        <p:nvSpPr>
-          <p:cNvPr id="2" name="Title 1">
-            <a:extLst>
-              <a:ext uri="{FF2B5EF4-FFF2-40B4-BE49-F238E27FC236}">
-                <a16:creationId xmlns:a16="http://schemas.microsoft.com/office/drawing/2014/main" id="{D09F8BDE-5401-629F-833C-3B2919397616}"/>
-              </a:ext>
-            </a:extLst>
-          </p:cNvPr>
-          <p:cNvSpPr>
-            <a:spLocks noGrp="1"/>
-          </p:cNvSpPr>
-          <p:nvPr>
-            <p:ph type="title"/>
-          </p:nvPr>
-        </p:nvSpPr>
-        <p:spPr>
-          <a:xfrm>
-            <a:off x="1154953" y="744117"/>
-            <a:ext cx="3401064" cy="903514"/>
-          </a:xfrm>
-        </p:spPr>
-        <p:txBody>
-          <a:bodyPr/>
-          <a:lstStyle/>
-          <a:p>
-            <a:r>
-              <a:rPr lang="en-US" dirty="0"/>
-              <a:t>Delivery Context</a:t>
-            </a:r>
-          </a:p>
-        </p:txBody>
-      </p:sp>
-      <p:sp>
-        <p:nvSpPr>
-          <p:cNvPr id="3" name="Content Placeholder 2">
-            <a:extLst>
-              <a:ext uri="{FF2B5EF4-FFF2-40B4-BE49-F238E27FC236}">
-                <a16:creationId xmlns:a16="http://schemas.microsoft.com/office/drawing/2014/main" id="{E361027E-A33B-9448-E3B1-10B84F72C042}"/>
-              </a:ext>
-            </a:extLst>
-          </p:cNvPr>
-          <p:cNvSpPr>
-            <a:spLocks noGrp="1"/>
-          </p:cNvSpPr>
-          <p:nvPr>
-            <p:ph idx="1"/>
-          </p:nvPr>
-        </p:nvSpPr>
-        <p:spPr/>
-        <p:txBody>
-          <a:bodyPr/>
-          <a:lstStyle/>
-          <a:p>
-            <a:pPr marL="0" indent="0">
-              <a:buNone/>
-            </a:pPr>
-            <a:r>
-              <a:rPr lang="en-US" dirty="0"/>
-              <a:t>At the time of this assignment, we would have previously discussed these topics:</a:t>
-            </a:r>
-          </a:p>
-          <a:p>
-            <a:r>
-              <a:rPr lang="en-US" dirty="0"/>
-              <a:t>key terms/ Influential people: “Black women, stereotype; Maya Angelou, Bell Hooks</a:t>
-            </a:r>
-          </a:p>
-          <a:p>
-            <a:r>
-              <a:rPr lang="en-US" dirty="0"/>
-              <a:t>Major stereotypes: Mammy, Jezebel, Light skin(Mulatto), Angry black women</a:t>
-            </a:r>
-          </a:p>
-          <a:p>
-            <a:r>
-              <a:rPr lang="en-US" dirty="0"/>
-              <a:t> Conducted a case study on at least one poem, TikTok, a painting, and the film Sinners.</a:t>
-            </a:r>
-          </a:p>
-        </p:txBody>
-      </p:sp>
-      <p:sp>
-        <p:nvSpPr>
-          <p:cNvPr id="4" name="Text Placeholder 3">
-            <a:extLst>
-              <a:ext uri="{FF2B5EF4-FFF2-40B4-BE49-F238E27FC236}">
-                <a16:creationId xmlns:a16="http://schemas.microsoft.com/office/drawing/2014/main" id="{800D62F0-2A14-A9A6-2648-A94BE1111F6A}"/>
-              </a:ext>
-            </a:extLst>
-          </p:cNvPr>
-          <p:cNvSpPr>
-            <a:spLocks noGrp="1"/>
-          </p:cNvSpPr>
-          <p:nvPr>
-            <p:ph type="body" sz="half" idx="2"/>
-          </p:nvPr>
-        </p:nvSpPr>
-        <p:spPr>
-          <a:xfrm>
-            <a:off x="1154954" y="1940767"/>
-            <a:ext cx="3401063" cy="3721359"/>
-          </a:xfrm>
-        </p:spPr>
-        <p:txBody>
-          <a:bodyPr>
-            <a:normAutofit/>
-          </a:bodyPr>
-          <a:lstStyle/>
-          <a:p>
-            <a:r>
-              <a:rPr lang="en-US" dirty="0"/>
-              <a:t>Readings:</a:t>
-            </a:r>
-          </a:p>
-          <a:p>
-            <a:pPr marL="285750" indent="-285750">
-              <a:buFont typeface="Arial" panose="020B0604020202020204" pitchFamily="34" charset="0"/>
-              <a:buChar char="•"/>
-            </a:pPr>
-            <a:r>
-              <a:rPr lang="en-US" dirty="0"/>
-              <a:t>Key Questions to Ask when Analyzing Media Experiences: </a:t>
-            </a:r>
-            <a:r>
-              <a:rPr lang="en-US" dirty="0">
-                <a:hlinkClick r:id="rId2"/>
-              </a:rPr>
-              <a:t>https://namle.org/resources/key-questions-for-analyzing-media/</a:t>
-            </a:r>
-            <a:r>
-              <a:rPr lang="en-US" dirty="0"/>
-              <a:t> </a:t>
-            </a:r>
-          </a:p>
-          <a:p>
-            <a:pPr marL="285750" indent="-285750">
-              <a:buFont typeface="Arial" panose="020B0604020202020204" pitchFamily="34" charset="0"/>
-              <a:buChar char="•"/>
-            </a:pPr>
-            <a:r>
-              <a:rPr lang="en-US" dirty="0"/>
-              <a:t>Black Women’s Identity: Stereotypes, Respectability and </a:t>
-            </a:r>
-            <a:r>
-              <a:rPr lang="en-US" dirty="0" err="1"/>
-              <a:t>Passionlessness</a:t>
-            </a:r>
-            <a:r>
-              <a:rPr lang="en-US" dirty="0"/>
-              <a:t> (1890-1930): </a:t>
-            </a:r>
-            <a:r>
-              <a:rPr lang="en-US" dirty="0">
-                <a:hlinkClick r:id="rId3"/>
-              </a:rPr>
-              <a:t>https://journals.openedition.org/lisa/806</a:t>
-            </a:r>
-            <a:r>
-              <a:rPr lang="en-US" dirty="0"/>
-              <a:t> </a:t>
-            </a:r>
-          </a:p>
-          <a:p>
-            <a:pPr marL="285750" indent="-285750">
-              <a:buFont typeface="Arial" panose="020B0604020202020204" pitchFamily="34" charset="0"/>
-              <a:buChar char="•"/>
-            </a:pPr>
-            <a:r>
-              <a:rPr lang="en-US" dirty="0"/>
-              <a:t>Understanding -and avoiding- stereotypes about Black Women in the News: </a:t>
-            </a:r>
-            <a:r>
-              <a:rPr lang="en-US" dirty="0">
-                <a:hlinkClick r:id="rId4"/>
-              </a:rPr>
-              <a:t>https://nbcuacademy.com/black-women-stereotypes/</a:t>
-            </a:r>
-            <a:r>
-              <a:rPr lang="en-US" dirty="0"/>
-              <a:t> </a:t>
-            </a:r>
-          </a:p>
-        </p:txBody>
-      </p:sp>
-    </p:spTree>
-    <p:extLst>
-      <p:ext uri="{BB962C8B-B14F-4D97-AF65-F5344CB8AC3E}">
-        <p14:creationId xmlns:p14="http://schemas.microsoft.com/office/powerpoint/2010/main" val="1183801991"/>
-      </p:ext>
-    </p:extLst>
-  </p:cSld>
-  <p:clrMapOvr>
-    <a:masterClrMapping/>
-  </p:clrMapOvr>
-</p:sld>
-</file>
-
-<file path=ppt/slides/slide5.xml><?xml version="1.0" encoding="utf-8"?>
-<p:sld xmlns:a="http://schemas.openxmlformats.org/drawingml/2006/main" xmlns:r="http://schemas.openxmlformats.org/officeDocument/2006/relationships" xmlns:p="http://schemas.openxmlformats.org/presentationml/2006/main">
-  <p:cSld>
-    <p:spTree>
-      <p:nvGrpSpPr>
-        <p:cNvPr id="1" name=""/>
-        <p:cNvGrpSpPr/>
-        <p:nvPr/>
-      </p:nvGrpSpPr>
-      <p:grpSpPr>
-        <a:xfrm>
-          <a:off x="0" y="0"/>
-          <a:ext cx="0" cy="0"/>
-          <a:chOff x="0" y="0"/>
-          <a:chExt cx="0" cy="0"/>
-        </a:xfrm>
-      </p:grpSpPr>
-      <p:sp>
-        <p:nvSpPr>
-          <p:cNvPr id="4" name="TextBox 3">
-            <a:extLst>
-              <a:ext uri="{FF2B5EF4-FFF2-40B4-BE49-F238E27FC236}">
-                <a16:creationId xmlns:a16="http://schemas.microsoft.com/office/drawing/2014/main" id="{A6CFC9F6-FFD3-F852-0522-CE2BCFC13C12}"/>
-              </a:ext>
-            </a:extLst>
-          </p:cNvPr>
-          <p:cNvSpPr txBox="1"/>
-          <p:nvPr/>
-        </p:nvSpPr>
-        <p:spPr>
-          <a:xfrm>
-            <a:off x="823948" y="572763"/>
-            <a:ext cx="4670437" cy="584775"/>
-          </a:xfrm>
-          <a:prstGeom prst="rect">
-            <a:avLst/>
-          </a:prstGeom>
-          <a:noFill/>
-        </p:spPr>
-        <p:txBody>
-          <a:bodyPr wrap="square" rtlCol="0">
-            <a:spAutoFit/>
-          </a:bodyPr>
-          <a:lstStyle/>
-          <a:p>
-            <a:r>
-              <a:rPr lang="en-US" sz="3200" dirty="0">
-                <a:latin typeface="+mj-lt"/>
-              </a:rPr>
-              <a:t>Assignment goals</a:t>
-            </a:r>
-            <a:endParaRPr lang="en-US" sz="3200" dirty="0"/>
-          </a:p>
-        </p:txBody>
-      </p:sp>
-      <p:sp>
-        <p:nvSpPr>
-          <p:cNvPr id="5" name="TextBox 4">
-            <a:extLst>
-              <a:ext uri="{FF2B5EF4-FFF2-40B4-BE49-F238E27FC236}">
-                <a16:creationId xmlns:a16="http://schemas.microsoft.com/office/drawing/2014/main" id="{350A50A5-8BA6-1B5D-AD63-1618BEF3A9B6}"/>
-              </a:ext>
-            </a:extLst>
-          </p:cNvPr>
-          <p:cNvSpPr txBox="1"/>
-          <p:nvPr/>
-        </p:nvSpPr>
-        <p:spPr>
-          <a:xfrm>
-            <a:off x="693319" y="1340064"/>
-            <a:ext cx="10111530" cy="4401205"/>
-          </a:xfrm>
-          <a:prstGeom prst="rect">
-            <a:avLst/>
-          </a:prstGeom>
-          <a:noFill/>
-        </p:spPr>
-        <p:txBody>
-          <a:bodyPr wrap="square" rtlCol="0">
-            <a:spAutoFit/>
-          </a:bodyPr>
-          <a:lstStyle/>
-          <a:p>
-            <a:pPr marL="285750" indent="-285750">
-              <a:buFont typeface="Arial" panose="020B0604020202020204" pitchFamily="34" charset="0"/>
-              <a:buChar char="•"/>
-            </a:pPr>
-            <a:r>
-              <a:rPr lang="en-US" sz="2000" dirty="0">
-                <a:cs typeface="Times New Roman" panose="02020603050405020304" pitchFamily="18" charset="0"/>
-              </a:rPr>
-              <a:t>Students will select a piece of media (e.g., painting, text, film, photograph, song, or other artistic work) and conduct independent research to answer the question, "How are Black women being represented in this work?" </a:t>
-            </a:r>
-          </a:p>
-          <a:p>
-            <a:endParaRPr lang="en-US" sz="2000" dirty="0">
-              <a:cs typeface="Times New Roman" panose="02020603050405020304" pitchFamily="18" charset="0"/>
-            </a:endParaRPr>
-          </a:p>
-          <a:p>
-            <a:pPr marL="285750" indent="-285750">
-              <a:buFont typeface="Arial" panose="020B0604020202020204" pitchFamily="34" charset="0"/>
-              <a:buChar char="•"/>
-            </a:pPr>
-            <a:r>
-              <a:rPr lang="en-US" sz="2000" dirty="0">
-                <a:cs typeface="Times New Roman" panose="02020603050405020304" pitchFamily="18" charset="0"/>
-              </a:rPr>
-              <a:t>Students will produce a presentation that (a) states a clear thesis addressing this question, (b) synthesizes evidence from at least 3 sources (which may include scholarly criticism, historical context, or artist/creator background), and (c) cites all sources. </a:t>
-            </a:r>
-          </a:p>
-          <a:p>
-            <a:endParaRPr lang="en-US" sz="2000" dirty="0">
-              <a:cs typeface="Times New Roman" panose="02020603050405020304" pitchFamily="18" charset="0"/>
-            </a:endParaRPr>
-          </a:p>
-          <a:p>
-            <a:pPr marL="285750" indent="-285750">
-              <a:buFont typeface="Arial" panose="020B0604020202020204" pitchFamily="34" charset="0"/>
-              <a:buChar char="•"/>
-            </a:pPr>
-            <a:r>
-              <a:rPr lang="en-US" sz="2000" dirty="0">
-                <a:cs typeface="Times New Roman" panose="02020603050405020304" pitchFamily="18" charset="0"/>
-              </a:rPr>
-              <a:t>Students will also reflect on their experience creating the presentation, addressing why they chose that piece, what they learned about their chosen topic, how their research process shaped or changed their initial perspective, and what challenges they encountered.</a:t>
-            </a:r>
-            <a:br>
-              <a:rPr lang="en-US" sz="2000" dirty="0">
-                <a:cs typeface="Times New Roman" panose="02020603050405020304" pitchFamily="18" charset="0"/>
-              </a:rPr>
-            </a:br>
-            <a:endParaRPr lang="en-US" sz="2000" dirty="0">
-              <a:cs typeface="Times New Roman" panose="02020603050405020304" pitchFamily="18" charset="0"/>
-            </a:endParaRPr>
-          </a:p>
-        </p:txBody>
-      </p:sp>
-    </p:spTree>
-    <p:extLst>
-      <p:ext uri="{BB962C8B-B14F-4D97-AF65-F5344CB8AC3E}">
-        <p14:creationId xmlns:p14="http://schemas.microsoft.com/office/powerpoint/2010/main" val="1545177064"/>
-      </p:ext>
-    </p:extLst>
-  </p:cSld>
-  <p:clrMapOvr>
-    <a:masterClrMapping/>
-  </p:clrMapOvr>
-</p:sld>
-</file>
-
-<file path=ppt/slides/slide6.xml><?xml version="1.0" encoding="utf-8"?>
-<p:sld xmlns:a="http://schemas.openxmlformats.org/drawingml/2006/main" xmlns:r="http://schemas.openxmlformats.org/officeDocument/2006/relationships" xmlns:p="http://schemas.openxmlformats.org/presentationml/2006/main">
-  <p:cSld>
-    <p:spTree>
-      <p:nvGrpSpPr>
-        <p:cNvPr id="1" name=""/>
-        <p:cNvGrpSpPr/>
-        <p:nvPr/>
-      </p:nvGrpSpPr>
-      <p:grpSpPr>
-        <a:xfrm>
-          <a:off x="0" y="0"/>
-          <a:ext cx="0" cy="0"/>
-          <a:chOff x="0" y="0"/>
-          <a:chExt cx="0" cy="0"/>
-        </a:xfrm>
-      </p:grpSpPr>
-      <p:sp>
-        <p:nvSpPr>
-          <p:cNvPr id="2" name="Title 1">
-            <a:extLst>
-              <a:ext uri="{FF2B5EF4-FFF2-40B4-BE49-F238E27FC236}">
-                <a16:creationId xmlns:a16="http://schemas.microsoft.com/office/drawing/2014/main" id="{81896B45-59A7-C589-9ECA-BA4BE7D7D9F3}"/>
-              </a:ext>
-            </a:extLst>
-          </p:cNvPr>
-          <p:cNvSpPr>
-            <a:spLocks noGrp="1"/>
-          </p:cNvSpPr>
-          <p:nvPr>
-            <p:ph type="title"/>
-          </p:nvPr>
-        </p:nvSpPr>
-        <p:spPr>
-          <a:xfrm>
-            <a:off x="540723" y="346062"/>
-            <a:ext cx="1586657" cy="1650689"/>
-          </a:xfrm>
-        </p:spPr>
-        <p:txBody>
-          <a:bodyPr>
-            <a:normAutofit/>
-          </a:bodyPr>
-          <a:lstStyle/>
-          <a:p>
-            <a:r>
-              <a:rPr lang="en-US" sz="3200" dirty="0"/>
-              <a:t>Tasks</a:t>
-            </a:r>
-            <a:endParaRPr lang="en-US" dirty="0"/>
-          </a:p>
-        </p:txBody>
-      </p:sp>
-      <p:sp>
-        <p:nvSpPr>
-          <p:cNvPr id="5" name="Content Placeholder 4">
-            <a:extLst>
-              <a:ext uri="{FF2B5EF4-FFF2-40B4-BE49-F238E27FC236}">
-                <a16:creationId xmlns:a16="http://schemas.microsoft.com/office/drawing/2014/main" id="{FBFE3E85-F977-4917-D2F3-E64C503441F1}"/>
-              </a:ext>
-            </a:extLst>
-          </p:cNvPr>
-          <p:cNvSpPr>
-            <a:spLocks noGrp="1"/>
-          </p:cNvSpPr>
-          <p:nvPr>
-            <p:ph sz="quarter" idx="13"/>
-          </p:nvPr>
-        </p:nvSpPr>
-        <p:spPr>
-          <a:xfrm>
-            <a:off x="455418" y="859245"/>
-            <a:ext cx="11281163" cy="5410926"/>
-          </a:xfrm>
-        </p:spPr>
-        <p:txBody>
-          <a:bodyPr>
-            <a:noAutofit/>
-          </a:bodyPr>
-          <a:lstStyle/>
-          <a:p>
-            <a:r>
-              <a:rPr lang="en-US" sz="1150" dirty="0">
-                <a:latin typeface="+mn-lt"/>
-                <a:cs typeface="Times New Roman" panose="02020603050405020304" pitchFamily="18" charset="0"/>
-              </a:rPr>
-              <a:t>1) Choose one form of media to analyze. At least one black woman must be showcased in the piece.  Cannot use a piece already discussed in the course.</a:t>
-            </a:r>
-          </a:p>
-          <a:p>
-            <a:pPr lvl="1" fontAlgn="base"/>
-            <a:r>
-              <a:rPr lang="en-US" sz="1100" dirty="0">
-                <a:latin typeface="+mn-lt"/>
-                <a:cs typeface="Times New Roman" panose="02020603050405020304" pitchFamily="18" charset="0"/>
-              </a:rPr>
-              <a:t>Examples could include a music video, song lyrics, a movie, a television show, a book, a poem, a meme, a performance, physical art: (painting, drawing, sculpture), court case,  or viral TikTok </a:t>
-            </a:r>
-          </a:p>
-          <a:p>
-            <a:pPr lvl="1" fontAlgn="base"/>
-            <a:r>
-              <a:rPr lang="en-US" sz="1100" dirty="0">
-                <a:latin typeface="+mn-lt"/>
-                <a:cs typeface="Times New Roman" panose="02020603050405020304" pitchFamily="18" charset="0"/>
-              </a:rPr>
-              <a:t>If choosing a movie, show, or book, focus on one of the following: a specific scene, plot point, or character.</a:t>
-            </a:r>
-          </a:p>
-          <a:p>
-            <a:pPr lvl="1" fontAlgn="base"/>
-            <a:r>
-              <a:rPr lang="en-US" sz="1100" dirty="0">
-                <a:latin typeface="+mn-lt"/>
-                <a:cs typeface="Times New Roman" panose="02020603050405020304" pitchFamily="18" charset="0"/>
-              </a:rPr>
-              <a:t>Feel free to extend beyond these examples</a:t>
-            </a:r>
-          </a:p>
-          <a:p>
-            <a:r>
-              <a:rPr lang="en-US" sz="1100" dirty="0">
-                <a:latin typeface="+mn-lt"/>
-                <a:cs typeface="Times New Roman" panose="02020603050405020304" pitchFamily="18" charset="0"/>
-              </a:rPr>
-              <a:t>2) Examine the Black woman in the context of the piece</a:t>
-            </a:r>
-          </a:p>
-          <a:p>
-            <a:pPr lvl="1" fontAlgn="base"/>
-            <a:r>
-              <a:rPr lang="en-US" sz="1100" dirty="0">
-                <a:latin typeface="+mn-lt"/>
-                <a:cs typeface="Times New Roman" panose="02020603050405020304" pitchFamily="18" charset="0"/>
-              </a:rPr>
-              <a:t>Include the creator/author/originator, identify subject matters, include background: setting, cultural relevance, historical context, identify tropes, etc.</a:t>
-            </a:r>
-          </a:p>
-          <a:p>
-            <a:pPr lvl="1" fontAlgn="base"/>
-            <a:r>
-              <a:rPr lang="en-US" sz="1100" dirty="0">
-                <a:latin typeface="+mn-lt"/>
-                <a:cs typeface="Times New Roman" panose="02020603050405020304" pitchFamily="18" charset="0"/>
-              </a:rPr>
-              <a:t>Look at how the black woman’s presence affects or is affecting the work.</a:t>
-            </a:r>
-          </a:p>
-          <a:p>
-            <a:pPr lvl="1" fontAlgn="base"/>
-            <a:r>
-              <a:rPr lang="en-US" sz="1100" dirty="0">
-                <a:latin typeface="+mn-lt"/>
-                <a:cs typeface="Times New Roman" panose="02020603050405020304" pitchFamily="18" charset="0"/>
-              </a:rPr>
-              <a:t>Keep a record of the sources of your research; this should be included in the reflection and should be mentioned in the presentation where applicable. </a:t>
-            </a:r>
-          </a:p>
-          <a:p>
-            <a:r>
-              <a:rPr lang="en-US" sz="1100" dirty="0">
-                <a:latin typeface="+mn-lt"/>
-                <a:cs typeface="Times New Roman" panose="02020603050405020304" pitchFamily="18" charset="0"/>
-              </a:rPr>
-              <a:t>3) Create a presentation about your medium between 4 </a:t>
-            </a:r>
-            <a:r>
-              <a:rPr lang="en-US" sz="1100">
-                <a:latin typeface="+mn-lt"/>
-                <a:cs typeface="Times New Roman" panose="02020603050405020304" pitchFamily="18" charset="0"/>
-              </a:rPr>
-              <a:t>and 12 </a:t>
-            </a:r>
-            <a:r>
-              <a:rPr lang="en-US" sz="1100" dirty="0">
-                <a:latin typeface="+mn-lt"/>
-                <a:cs typeface="Times New Roman" panose="02020603050405020304" pitchFamily="18" charset="0"/>
-              </a:rPr>
-              <a:t>minutes. 70 points</a:t>
-            </a:r>
-          </a:p>
-          <a:p>
-            <a:pPr lvl="1" fontAlgn="base"/>
-            <a:r>
-              <a:rPr lang="en-US" sz="1100" dirty="0">
-                <a:latin typeface="+mn-lt"/>
-                <a:cs typeface="Times New Roman" panose="02020603050405020304" pitchFamily="18" charset="0"/>
-              </a:rPr>
-              <a:t>Include a thesis statement in the first minute of the presentation addressing "How are black women being represented?“</a:t>
-            </a:r>
-          </a:p>
-          <a:p>
-            <a:pPr lvl="1" fontAlgn="base"/>
-            <a:r>
-              <a:rPr lang="en-US" sz="1100" dirty="0">
-                <a:latin typeface="+mn-lt"/>
-                <a:cs typeface="Times New Roman" panose="02020603050405020304" pitchFamily="18" charset="0"/>
-              </a:rPr>
-              <a:t>Consider items like narrative point of view, casting, symbolism, dialogue, word choice, author/producer motivations, </a:t>
-            </a:r>
-          </a:p>
-          <a:p>
-            <a:pPr lvl="1" fontAlgn="base"/>
-            <a:r>
-              <a:rPr lang="en-US" sz="1100" dirty="0">
-                <a:latin typeface="+mn-lt"/>
-                <a:cs typeface="Times New Roman" panose="02020603050405020304" pitchFamily="18" charset="0"/>
-              </a:rPr>
-              <a:t>Include a moving element (PowerPoint, slide deck, video, song, voice recording, graphic, etc.</a:t>
-            </a:r>
-          </a:p>
-          <a:p>
-            <a:pPr lvl="1" fontAlgn="base"/>
-            <a:r>
-              <a:rPr lang="en-US" sz="1100" dirty="0">
-                <a:latin typeface="+mn-lt"/>
-                <a:cs typeface="Times New Roman" panose="02020603050405020304" pitchFamily="18" charset="0"/>
-              </a:rPr>
-              <a:t>In the presentation, you must provide a link to the piece or include a picture or link to a summary of the piece you have chosen for a book, television show, or movie.</a:t>
-            </a:r>
-          </a:p>
-          <a:p>
-            <a:r>
-              <a:rPr lang="en-US" sz="1100" dirty="0">
-                <a:latin typeface="+mn-lt"/>
-                <a:cs typeface="Times New Roman" panose="02020603050405020304" pitchFamily="18" charset="0"/>
-              </a:rPr>
-              <a:t>4) Create a reflection 30 points</a:t>
-            </a:r>
-          </a:p>
-          <a:p>
-            <a:pPr lvl="1" fontAlgn="base"/>
-            <a:r>
-              <a:rPr lang="en-US" sz="1100" dirty="0">
-                <a:latin typeface="+mn-lt"/>
-                <a:cs typeface="Times New Roman" panose="02020603050405020304" pitchFamily="18" charset="0"/>
-              </a:rPr>
-              <a:t>Include a separate video or written piece explaining why you chose the piece you did and why you chose to present the information in the manner you did. </a:t>
-            </a:r>
-          </a:p>
-          <a:p>
-            <a:pPr lvl="1" fontAlgn="base"/>
-            <a:r>
-              <a:rPr lang="en-US" sz="1100" dirty="0">
-                <a:latin typeface="+mn-lt"/>
-                <a:cs typeface="Times New Roman" panose="02020603050405020304" pitchFamily="18" charset="0"/>
-              </a:rPr>
-              <a:t>Include citations for research.</a:t>
-            </a:r>
-          </a:p>
-          <a:p>
-            <a:pPr lvl="1" fontAlgn="base"/>
-            <a:r>
-              <a:rPr lang="en-US" sz="1100" dirty="0">
-                <a:latin typeface="+mn-lt"/>
-                <a:cs typeface="Times New Roman" panose="02020603050405020304" pitchFamily="18" charset="0"/>
-              </a:rPr>
-              <a:t>No word count or time length required; both questions must be addressed for full credit.</a:t>
-            </a:r>
-          </a:p>
-        </p:txBody>
-      </p:sp>
-    </p:spTree>
-    <p:extLst>
-      <p:ext uri="{BB962C8B-B14F-4D97-AF65-F5344CB8AC3E}">
-        <p14:creationId xmlns:p14="http://schemas.microsoft.com/office/powerpoint/2010/main" val="1566291291"/>
-      </p:ext>
-    </p:extLst>
-  </p:cSld>
-  <p:clrMapOvr>
-    <a:masterClrMapping/>
-  </p:clrMapOvr>
-</p:sld>
-</file>
-
-<file path=ppt/slides/slide7.xml><?xml version="1.0" encoding="utf-8"?>
-<p:sld xmlns:a="http://schemas.openxmlformats.org/drawingml/2006/main" xmlns:r="http://schemas.openxmlformats.org/officeDocument/2006/relationships" xmlns:p="http://schemas.openxmlformats.org/presentationml/2006/main">
-  <p:cSld>
-    <p:bg>
-      <p:bgPr>
-        <a:blipFill rotWithShape="1">
-          <a:blip r:embed="rId2">
-            <a:duotone>
-              <a:schemeClr val="bg2">
-                <a:shade val="69000"/>
-                <a:hueMod val="108000"/>
-                <a:satMod val="164000"/>
-                <a:lumMod val="74000"/>
-              </a:schemeClr>
-              <a:schemeClr val="bg2">
-                <a:tint val="96000"/>
-                <a:hueMod val="88000"/>
-                <a:satMod val="140000"/>
-                <a:lumMod val="132000"/>
-              </a:schemeClr>
-            </a:duotone>
-          </a:blip>
-          <a:stretch/>
-        </a:blipFill>
-        <a:effectLst/>
-      </p:bgPr>
-    </p:bg>
-    <p:spTree>
-      <p:nvGrpSpPr>
-        <p:cNvPr id="1" name=""/>
-        <p:cNvGrpSpPr/>
-        <p:nvPr/>
-      </p:nvGrpSpPr>
-      <p:grpSpPr>
-        <a:xfrm>
-          <a:off x="0" y="0"/>
-          <a:ext cx="0" cy="0"/>
-          <a:chOff x="0" y="0"/>
-          <a:chExt cx="0" cy="0"/>
-        </a:xfrm>
-      </p:grpSpPr>
-      <p:pic>
-        <p:nvPicPr>
-          <p:cNvPr id="66" name="Picture 65">
-            <a:extLst>
-              <a:ext uri="{FF2B5EF4-FFF2-40B4-BE49-F238E27FC236}">
-                <a16:creationId xmlns:a16="http://schemas.microsoft.com/office/drawing/2014/main" id="{DF19BAF3-7E20-4B9D-B544-BABAEEA1FA75}"/>
-              </a:ext>
-              <a:ext uri="{C183D7F6-B498-43B3-948B-1728B52AA6E4}">
-                <adec:decorative xmlns:adec="http://schemas.microsoft.com/office/drawing/2017/decorative" val="1"/>
-              </a:ext>
-            </a:extLst>
-          </p:cNvPr>
-          <p:cNvPicPr>
-            <a:picLocks noGrp="1" noRot="1" noChangeAspect="1" noMove="1" noResize="1" noEditPoints="1" noAdjustHandles="1" noChangeArrowheads="1" noChangeShapeType="1" noCrop="1"/>
-          </p:cNvPicPr>
-          <p:nvPr>
-            <p:extLst>
-              <p:ext uri="{386F3935-93C4-4BCD-93E2-E3B085C9AB24}">
-                <p16:designElem xmlns:p16="http://schemas.microsoft.com/office/powerpoint/2015/main" val="1"/>
-              </p:ext>
-            </p:extLst>
-          </p:nvPr>
-        </p:nvPicPr>
-        <p:blipFill rotWithShape="1">
-          <a:blip r:embed="rId3">
-            <a:extLst>
-              <a:ext uri="{28A0092B-C50C-407E-A947-70E740481C1C}">
-                <a14:useLocalDpi xmlns:a14="http://schemas.microsoft.com/office/drawing/2010/main" val="0"/>
-              </a:ext>
-            </a:extLst>
-          </a:blip>
-          <a:srcRect l="3613"/>
-          <a:stretch/>
-        </p:blipFill>
-        <p:spPr>
-          <a:xfrm>
-            <a:off x="0" y="2669685"/>
-            <a:ext cx="4037012" cy="4188315"/>
-          </a:xfrm>
-          <a:prstGeom prst="rect">
-            <a:avLst/>
-          </a:prstGeom>
-        </p:spPr>
-      </p:pic>
-      <p:pic>
-        <p:nvPicPr>
-          <p:cNvPr id="67" name="Picture 66">
-            <a:extLst>
-              <a:ext uri="{FF2B5EF4-FFF2-40B4-BE49-F238E27FC236}">
-                <a16:creationId xmlns:a16="http://schemas.microsoft.com/office/drawing/2014/main" id="{950648F4-ABCD-4DF0-8641-76CFB2354721}"/>
-              </a:ext>
-              <a:ext uri="{C183D7F6-B498-43B3-948B-1728B52AA6E4}">
-                <adec:decorative xmlns:adec="http://schemas.microsoft.com/office/drawing/2017/decorative" val="1"/>
-              </a:ext>
-            </a:extLst>
-          </p:cNvPr>
-          <p:cNvPicPr>
-            <a:picLocks noGrp="1" noRot="1" noChangeAspect="1" noMove="1" noResize="1" noEditPoints="1" noAdjustHandles="1" noChangeArrowheads="1" noChangeShapeType="1" noCrop="1"/>
-          </p:cNvPicPr>
-          <p:nvPr>
-            <p:extLst>
-              <p:ext uri="{386F3935-93C4-4BCD-93E2-E3B085C9AB24}">
-                <p16:designElem xmlns:p16="http://schemas.microsoft.com/office/powerpoint/2015/main" val="1"/>
-              </p:ext>
-            </p:extLst>
-          </p:nvPr>
-        </p:nvPicPr>
-        <p:blipFill rotWithShape="1">
-          <a:blip r:embed="rId4">
-            <a:extLst>
-              <a:ext uri="{28A0092B-C50C-407E-A947-70E740481C1C}">
-                <a14:useLocalDpi xmlns:a14="http://schemas.microsoft.com/office/drawing/2010/main" val="0"/>
-              </a:ext>
-            </a:extLst>
-          </a:blip>
-          <a:srcRect l="35640"/>
-          <a:stretch/>
-        </p:blipFill>
-        <p:spPr>
-          <a:xfrm>
-            <a:off x="0" y="2892347"/>
-            <a:ext cx="1522412" cy="2365453"/>
-          </a:xfrm>
-          <a:prstGeom prst="rect">
-            <a:avLst/>
-          </a:prstGeom>
-        </p:spPr>
-      </p:pic>
-      <p:sp>
-        <p:nvSpPr>
-          <p:cNvPr id="68" name="Oval 67">
-            <a:extLst>
-              <a:ext uri="{FF2B5EF4-FFF2-40B4-BE49-F238E27FC236}">
-                <a16:creationId xmlns:a16="http://schemas.microsoft.com/office/drawing/2014/main" id="{989BE678-777B-482A-A616-FEDC47B162E5}"/>
-              </a:ext>
-              <a:ext uri="{C183D7F6-B498-43B3-948B-1728B52AA6E4}">
-                <adec:decorative xmlns:adec="http://schemas.microsoft.com/office/drawing/2017/decorative" val="1"/>
-              </a:ext>
-            </a:extLst>
-          </p:cNvPr>
-          <p:cNvSpPr>
-            <a:spLocks noGrp="1" noRot="1" noChangeAspect="1" noMove="1" noResize="1" noEditPoints="1" noAdjustHandles="1" noChangeArrowheads="1" noChangeShapeType="1" noTextEdit="1"/>
-          </p:cNvSpPr>
-          <p:nvPr>
-            <p:extLst>
-              <p:ext uri="{386F3935-93C4-4BCD-93E2-E3B085C9AB24}">
-                <p16:designElem xmlns:p16="http://schemas.microsoft.com/office/powerpoint/2015/main" val="1"/>
-              </p:ext>
-            </p:extLst>
-          </p:nvPr>
-        </p:nvSpPr>
-        <p:spPr>
-          <a:xfrm>
-            <a:off x="8609012" y="1676400"/>
-            <a:ext cx="2819400" cy="2819400"/>
-          </a:xfrm>
-          <a:prstGeom prst="ellipse">
-            <a:avLst/>
-          </a:prstGeom>
-          <a:gradFill flip="none" rotWithShape="1">
-            <a:gsLst>
-              <a:gs pos="0">
-                <a:schemeClr val="bg2">
-                  <a:lumMod val="60000"/>
-                  <a:lumOff val="40000"/>
-                  <a:alpha val="7000"/>
-                </a:schemeClr>
-              </a:gs>
-              <a:gs pos="69000">
-                <a:schemeClr val="bg2">
-                  <a:lumMod val="60000"/>
-                  <a:lumOff val="40000"/>
-                  <a:alpha val="0"/>
-                </a:schemeClr>
-              </a:gs>
-              <a:gs pos="36000">
-                <a:schemeClr val="bg2">
-                  <a:lumMod val="60000"/>
-                  <a:lumOff val="40000"/>
-                  <a:alpha val="6000"/>
-                </a:schemeClr>
-              </a:gs>
-            </a:gsLst>
-            <a:path path="circle">
-              <a:fillToRect l="50000" t="50000" r="50000" b="50000"/>
-            </a:path>
-            <a:tileRect/>
-          </a:gradFill>
-          <a:ln>
-            <a:noFill/>
-          </a:ln>
-          <a:effectLst/>
-        </p:spPr>
-        <p:style>
-          <a:lnRef idx="1">
-            <a:schemeClr val="accent1"/>
-          </a:lnRef>
-          <a:fillRef idx="3">
-            <a:schemeClr val="accent1"/>
-          </a:fillRef>
-          <a:effectRef idx="2">
-            <a:schemeClr val="accent1"/>
-          </a:effectRef>
-          <a:fontRef idx="minor">
-            <a:schemeClr val="lt1"/>
-          </a:fontRef>
-        </p:style>
-        <p:txBody>
-          <a:bodyPr/>
-          <a:lstStyle/>
-          <a:p>
-            <a:endParaRPr lang="en-US"/>
-          </a:p>
-        </p:txBody>
-      </p:sp>
-      <p:pic>
-        <p:nvPicPr>
-          <p:cNvPr id="69" name="Picture 68">
-            <a:extLst>
-              <a:ext uri="{FF2B5EF4-FFF2-40B4-BE49-F238E27FC236}">
-                <a16:creationId xmlns:a16="http://schemas.microsoft.com/office/drawing/2014/main" id="{CF1EB4BD-9C7E-4AA3-9681-C7EB0DA6250B}"/>
-              </a:ext>
-              <a:ext uri="{C183D7F6-B498-43B3-948B-1728B52AA6E4}">
-                <adec:decorative xmlns:adec="http://schemas.microsoft.com/office/drawing/2017/decorative" val="1"/>
-              </a:ext>
-            </a:extLst>
-          </p:cNvPr>
-          <p:cNvPicPr>
-            <a:picLocks noGrp="1" noRot="1" noChangeAspect="1" noMove="1" noResize="1" noEditPoints="1" noAdjustHandles="1" noChangeArrowheads="1" noChangeShapeType="1" noCrop="1"/>
-          </p:cNvPicPr>
-          <p:nvPr>
-            <p:extLst>
-              <p:ext uri="{386F3935-93C4-4BCD-93E2-E3B085C9AB24}">
-                <p16:designElem xmlns:p16="http://schemas.microsoft.com/office/powerpoint/2015/main" val="1"/>
-              </p:ext>
-            </p:extLst>
-          </p:nvPr>
-        </p:nvPicPr>
-        <p:blipFill rotWithShape="1">
-          <a:blip r:embed="rId5">
-            <a:extLst>
-              <a:ext uri="{28A0092B-C50C-407E-A947-70E740481C1C}">
-                <a14:useLocalDpi xmlns:a14="http://schemas.microsoft.com/office/drawing/2010/main" val="0"/>
-              </a:ext>
-            </a:extLst>
-          </a:blip>
-          <a:srcRect t="28813"/>
-          <a:stretch/>
-        </p:blipFill>
-        <p:spPr>
-          <a:xfrm>
-            <a:off x="7999412" y="0"/>
-            <a:ext cx="1603387" cy="1141407"/>
-          </a:xfrm>
-          <a:prstGeom prst="rect">
-            <a:avLst/>
-          </a:prstGeom>
-        </p:spPr>
-      </p:pic>
-      <p:pic>
-        <p:nvPicPr>
-          <p:cNvPr id="70" name="Picture 69">
-            <a:extLst>
-              <a:ext uri="{FF2B5EF4-FFF2-40B4-BE49-F238E27FC236}">
-                <a16:creationId xmlns:a16="http://schemas.microsoft.com/office/drawing/2014/main" id="{94AAE3AA-3759-4D28-B0EF-575F25A5146C}"/>
-              </a:ext>
-              <a:ext uri="{C183D7F6-B498-43B3-948B-1728B52AA6E4}">
-                <adec:decorative xmlns:adec="http://schemas.microsoft.com/office/drawing/2017/decorative" val="1"/>
-              </a:ext>
-            </a:extLst>
-          </p:cNvPr>
-          <p:cNvPicPr>
-            <a:picLocks noGrp="1" noRot="1" noChangeAspect="1" noMove="1" noResize="1" noEditPoints="1" noAdjustHandles="1" noChangeArrowheads="1" noChangeShapeType="1" noCrop="1"/>
-          </p:cNvPicPr>
-          <p:nvPr>
-            <p:extLst>
-              <p:ext uri="{386F3935-93C4-4BCD-93E2-E3B085C9AB24}">
-                <p16:designElem xmlns:p16="http://schemas.microsoft.com/office/powerpoint/2015/main" val="1"/>
-              </p:ext>
-            </p:extLst>
-          </p:nvPr>
-        </p:nvPicPr>
-        <p:blipFill rotWithShape="1">
-          <a:blip r:embed="rId6">
-            <a:extLst>
-              <a:ext uri="{28A0092B-C50C-407E-A947-70E740481C1C}">
-                <a14:useLocalDpi xmlns:a14="http://schemas.microsoft.com/office/drawing/2010/main" val="0"/>
-              </a:ext>
-            </a:extLst>
-          </a:blip>
-          <a:srcRect b="23320"/>
-          <a:stretch/>
-        </p:blipFill>
-        <p:spPr>
-          <a:xfrm>
-            <a:off x="8605878" y="6096000"/>
-            <a:ext cx="993734" cy="762000"/>
-          </a:xfrm>
-          <a:prstGeom prst="rect">
-            <a:avLst/>
-          </a:prstGeom>
-        </p:spPr>
-      </p:pic>
-      <p:sp>
-        <p:nvSpPr>
-          <p:cNvPr id="71" name="Rectangle 70">
-            <a:extLst>
-              <a:ext uri="{FF2B5EF4-FFF2-40B4-BE49-F238E27FC236}">
-                <a16:creationId xmlns:a16="http://schemas.microsoft.com/office/drawing/2014/main" id="{D28BE0C3-2102-4820-B88B-A448B1840D14}"/>
-              </a:ext>
-              <a:ext uri="{C183D7F6-B498-43B3-948B-1728B52AA6E4}">
-                <adec:decorative xmlns:adec="http://schemas.microsoft.com/office/drawing/2017/decorative" val="1"/>
-              </a:ext>
-            </a:extLst>
-          </p:cNvPr>
-          <p:cNvSpPr>
-            <a:spLocks noGrp="1" noRot="1" noChangeAspect="1" noMove="1" noResize="1" noEditPoints="1" noAdjustHandles="1" noChangeArrowheads="1" noChangeShapeType="1" noTextEdit="1"/>
-          </p:cNvSpPr>
-          <p:nvPr>
-            <p:extLst>
-              <p:ext uri="{386F3935-93C4-4BCD-93E2-E3B085C9AB24}">
-                <p16:designElem xmlns:p16="http://schemas.microsoft.com/office/powerpoint/2015/main" val="1"/>
-              </p:ext>
-            </p:extLst>
-          </p:nvPr>
-        </p:nvSpPr>
-        <p:spPr>
-          <a:xfrm>
-            <a:off x="10437812" y="0"/>
-            <a:ext cx="685800" cy="1143000"/>
-          </a:xfrm>
-          <a:prstGeom prst="rect">
-            <a:avLst/>
-          </a:prstGeom>
-          <a:solidFill>
-            <a:schemeClr val="accent1"/>
-          </a:solidFill>
-          <a:ln>
-            <a:noFill/>
-          </a:ln>
-        </p:spPr>
-        <p:style>
-          <a:lnRef idx="1">
-            <a:schemeClr val="accent1"/>
-          </a:lnRef>
-          <a:fillRef idx="3">
-            <a:schemeClr val="accent1"/>
-          </a:fillRef>
-          <a:effectRef idx="2">
-            <a:schemeClr val="accent1"/>
-          </a:effectRef>
-          <a:fontRef idx="minor">
-            <a:schemeClr val="lt1"/>
-          </a:fontRef>
-        </p:style>
-        <p:txBody>
-          <a:bodyPr/>
-          <a:lstStyle/>
-          <a:p>
-            <a:endParaRPr lang="en-US"/>
-          </a:p>
-        </p:txBody>
-      </p:sp>
-      <p:sp>
-        <p:nvSpPr>
-          <p:cNvPr id="72" name="Rectangle 71">
-            <a:extLst>
-              <a:ext uri="{FF2B5EF4-FFF2-40B4-BE49-F238E27FC236}">
-                <a16:creationId xmlns:a16="http://schemas.microsoft.com/office/drawing/2014/main" id="{C8A3C342-1D03-412F-8DD3-BF519E8E0AE9}"/>
-              </a:ext>
-              <a:ext uri="{C183D7F6-B498-43B3-948B-1728B52AA6E4}">
-                <adec:decorative xmlns:adec="http://schemas.microsoft.com/office/drawing/2017/decorative" val="1"/>
-              </a:ext>
-            </a:extLst>
-          </p:cNvPr>
-          <p:cNvSpPr>
-            <a:spLocks noGrp="1" noRot="1" noChangeAspect="1" noMove="1" noResize="1" noEditPoints="1" noAdjustHandles="1" noChangeArrowheads="1" noChangeShapeType="1" noTextEdit="1"/>
-          </p:cNvSpPr>
-          <p:nvPr>
-            <p:extLst>
-              <p:ext uri="{386F3935-93C4-4BCD-93E2-E3B085C9AB24}">
-                <p16:designElem xmlns:p16="http://schemas.microsoft.com/office/powerpoint/2015/main" val="1"/>
-              </p:ext>
-            </p:extLst>
-          </p:nvPr>
-        </p:nvSpPr>
-        <p:spPr>
-          <a:xfrm>
-            <a:off x="0" y="0"/>
-            <a:ext cx="12192000" cy="6858000"/>
-          </a:xfrm>
-          <a:prstGeom prst="rect">
-            <a:avLst/>
-          </a:prstGeom>
-          <a:ln>
-            <a:noFill/>
-          </a:ln>
-        </p:spPr>
-        <p:style>
-          <a:lnRef idx="2">
-            <a:schemeClr val="accent1">
-              <a:shade val="50000"/>
-            </a:schemeClr>
-          </a:lnRef>
-          <a:fillRef idx="1003">
-            <a:schemeClr val="dk2"/>
-          </a:fillRef>
-          <a:effectRef idx="0">
-            <a:schemeClr val="accent1"/>
-          </a:effectRef>
-          <a:fontRef idx="minor">
-            <a:schemeClr val="lt1"/>
-          </a:fontRef>
-        </p:style>
-        <p:txBody>
-          <a:bodyPr rtlCol="0" anchor="ctr"/>
-          <a:lstStyle/>
-          <a:p>
-            <a:pPr algn="ctr"/>
-            <a:endParaRPr lang="en-US"/>
-          </a:p>
-        </p:txBody>
-      </p:sp>
-      <p:sp>
-        <p:nvSpPr>
-          <p:cNvPr id="2" name="Title 1">
-            <a:extLst>
-              <a:ext uri="{FF2B5EF4-FFF2-40B4-BE49-F238E27FC236}">
-                <a16:creationId xmlns:a16="http://schemas.microsoft.com/office/drawing/2014/main" id="{6345782E-E94C-F7FF-5DDC-7C1DFF856F9E}"/>
-              </a:ext>
-            </a:extLst>
-          </p:cNvPr>
-          <p:cNvSpPr>
-            <a:spLocks noGrp="1"/>
-          </p:cNvSpPr>
-          <p:nvPr>
-            <p:ph type="title"/>
-          </p:nvPr>
-        </p:nvSpPr>
-        <p:spPr>
-          <a:xfrm>
-            <a:off x="648930" y="629266"/>
-            <a:ext cx="6188190" cy="1622321"/>
-          </a:xfrm>
-        </p:spPr>
-        <p:txBody>
-          <a:bodyPr vert="horz" lIns="91440" tIns="45720" rIns="91440" bIns="45720" rtlCol="0" anchor="t">
-            <a:normAutofit/>
-          </a:bodyPr>
-          <a:lstStyle/>
-          <a:p>
-            <a:r>
-              <a:rPr lang="en-US">
-                <a:solidFill>
-                  <a:srgbClr val="EBEBEB"/>
-                </a:solidFill>
-              </a:rPr>
-              <a:t>Criteria</a:t>
-            </a:r>
-          </a:p>
-        </p:txBody>
-      </p:sp>
-      <p:sp>
-        <p:nvSpPr>
-          <p:cNvPr id="3" name="Content Placeholder 2">
-            <a:extLst>
-              <a:ext uri="{FF2B5EF4-FFF2-40B4-BE49-F238E27FC236}">
-                <a16:creationId xmlns:a16="http://schemas.microsoft.com/office/drawing/2014/main" id="{E1115141-87C9-23DF-ECBC-B828494C9F1E}"/>
-              </a:ext>
-            </a:extLst>
-          </p:cNvPr>
-          <p:cNvSpPr>
-            <a:spLocks noGrp="1"/>
-          </p:cNvSpPr>
-          <p:nvPr>
-            <p:ph sz="quarter" idx="14"/>
-          </p:nvPr>
-        </p:nvSpPr>
-        <p:spPr>
-          <a:xfrm>
-            <a:off x="470076" y="1440426"/>
-            <a:ext cx="6188189" cy="4926864"/>
-          </a:xfrm>
-        </p:spPr>
-        <p:txBody>
-          <a:bodyPr vert="horz" lIns="91440" tIns="45720" rIns="91440" bIns="45720" rtlCol="0">
-            <a:normAutofit fontScale="70000" lnSpcReduction="20000"/>
-          </a:bodyPr>
-          <a:lstStyle/>
-          <a:p>
-            <a:pPr>
-              <a:lnSpc>
-                <a:spcPct val="90000"/>
-              </a:lnSpc>
-            </a:pPr>
-            <a:r>
-              <a:rPr lang="en-US" dirty="0">
-                <a:solidFill>
-                  <a:srgbClr val="FFFFFF"/>
-                </a:solidFill>
-              </a:rPr>
-              <a:t>Presentation 70 points, Grading looking for the following</a:t>
-            </a:r>
-          </a:p>
-          <a:p>
-            <a:pPr fontAlgn="base">
-              <a:lnSpc>
-                <a:spcPct val="90000"/>
-              </a:lnSpc>
-            </a:pPr>
-            <a:r>
-              <a:rPr lang="en-US" dirty="0">
-                <a:solidFill>
-                  <a:srgbClr val="FFFFFF"/>
-                </a:solidFill>
-              </a:rPr>
-              <a:t>Addresses the question, " How are black women being presented in this work?"- 25pts</a:t>
-            </a:r>
-          </a:p>
-          <a:p>
-            <a:pPr fontAlgn="base">
-              <a:lnSpc>
-                <a:spcPct val="90000"/>
-              </a:lnSpc>
-            </a:pPr>
-            <a:r>
-              <a:rPr lang="en-US" dirty="0">
-                <a:solidFill>
-                  <a:srgbClr val="FFFFFF"/>
-                </a:solidFill>
-              </a:rPr>
-              <a:t>Coherent argument- 15pts</a:t>
-            </a:r>
-          </a:p>
-          <a:p>
-            <a:pPr lvl="1" fontAlgn="base">
-              <a:lnSpc>
-                <a:spcPct val="90000"/>
-              </a:lnSpc>
-            </a:pPr>
-            <a:r>
-              <a:rPr lang="en-US" sz="2000" dirty="0">
-                <a:solidFill>
-                  <a:srgbClr val="FFFFFF"/>
-                </a:solidFill>
-              </a:rPr>
-              <a:t> Include what tools are being used to portray perspective</a:t>
-            </a:r>
-          </a:p>
-          <a:p>
-            <a:pPr lvl="1" fontAlgn="base">
-              <a:lnSpc>
-                <a:spcPct val="90000"/>
-              </a:lnSpc>
-            </a:pPr>
-            <a:r>
-              <a:rPr lang="en-US" sz="2000" dirty="0">
-                <a:solidFill>
-                  <a:srgbClr val="FFFFFF"/>
-                </a:solidFill>
-              </a:rPr>
-              <a:t>Should include where the information stems from, where relevant</a:t>
-            </a:r>
-          </a:p>
-          <a:p>
-            <a:pPr lvl="1" fontAlgn="base">
-              <a:lnSpc>
-                <a:spcPct val="90000"/>
-              </a:lnSpc>
-            </a:pPr>
-            <a:r>
-              <a:rPr lang="en-US" sz="2000" dirty="0">
-                <a:solidFill>
-                  <a:srgbClr val="FFFFFF"/>
-                </a:solidFill>
-              </a:rPr>
-              <a:t>Clear language</a:t>
-            </a:r>
-          </a:p>
-          <a:p>
-            <a:pPr lvl="1" fontAlgn="base">
-              <a:lnSpc>
-                <a:spcPct val="90000"/>
-              </a:lnSpc>
-            </a:pPr>
-            <a:r>
-              <a:rPr lang="en-US" sz="2000" dirty="0">
-                <a:solidFill>
-                  <a:srgbClr val="FFFFFF"/>
-                </a:solidFill>
-              </a:rPr>
-              <a:t>Minimal errors in spelling</a:t>
-            </a:r>
-          </a:p>
-          <a:p>
-            <a:pPr fontAlgn="base">
-              <a:lnSpc>
-                <a:spcPct val="90000"/>
-              </a:lnSpc>
-            </a:pPr>
-            <a:r>
-              <a:rPr lang="en-US" dirty="0">
-                <a:solidFill>
-                  <a:srgbClr val="FFFFFF"/>
-                </a:solidFill>
-              </a:rPr>
-              <a:t>Includes thesis statement within the first minute -10pts</a:t>
-            </a:r>
-          </a:p>
-          <a:p>
-            <a:pPr fontAlgn="base">
-              <a:lnSpc>
-                <a:spcPct val="90000"/>
-              </a:lnSpc>
-            </a:pPr>
-            <a:r>
-              <a:rPr lang="en-US" dirty="0">
-                <a:solidFill>
-                  <a:srgbClr val="FFFFFF"/>
-                </a:solidFill>
-              </a:rPr>
-              <a:t>Includes moving element- 10pts</a:t>
-            </a:r>
-          </a:p>
-          <a:p>
-            <a:pPr fontAlgn="base">
-              <a:lnSpc>
-                <a:spcPct val="90000"/>
-              </a:lnSpc>
-            </a:pPr>
-            <a:r>
-              <a:rPr lang="en-US" dirty="0">
-                <a:solidFill>
-                  <a:srgbClr val="FFFFFF"/>
-                </a:solidFill>
-              </a:rPr>
-              <a:t>Within the time frame 4-8 minutes- 5pts</a:t>
-            </a:r>
-          </a:p>
-          <a:p>
-            <a:pPr fontAlgn="base">
-              <a:lnSpc>
-                <a:spcPct val="90000"/>
-              </a:lnSpc>
-            </a:pPr>
-            <a:r>
-              <a:rPr lang="en-US" dirty="0">
-                <a:solidFill>
-                  <a:srgbClr val="FFFFFF"/>
-                </a:solidFill>
-              </a:rPr>
-              <a:t>Visually interesting- 5pts</a:t>
-            </a:r>
-          </a:p>
-          <a:p>
-            <a:pPr>
-              <a:lnSpc>
-                <a:spcPct val="90000"/>
-              </a:lnSpc>
-            </a:pPr>
-            <a:r>
-              <a:rPr lang="en-US" dirty="0">
-                <a:solidFill>
-                  <a:srgbClr val="FFFFFF"/>
-                </a:solidFill>
-              </a:rPr>
-              <a:t>Reflection 30pts</a:t>
-            </a:r>
-          </a:p>
-          <a:p>
-            <a:pPr lvl="1" fontAlgn="base">
-              <a:lnSpc>
-                <a:spcPct val="90000"/>
-              </a:lnSpc>
-            </a:pPr>
-            <a:r>
-              <a:rPr lang="en-US" sz="2000" dirty="0">
-                <a:solidFill>
-                  <a:srgbClr val="FFFFFF"/>
-                </a:solidFill>
-              </a:rPr>
-              <a:t>Explains why the piece was chosen-10pts</a:t>
-            </a:r>
-          </a:p>
-          <a:p>
-            <a:pPr lvl="1" fontAlgn="base">
-              <a:lnSpc>
-                <a:spcPct val="90000"/>
-              </a:lnSpc>
-            </a:pPr>
-            <a:r>
-              <a:rPr lang="en-US" sz="2000" dirty="0">
-                <a:solidFill>
-                  <a:srgbClr val="FFFFFF"/>
-                </a:solidFill>
-              </a:rPr>
-              <a:t>Explains what they learned -5pts</a:t>
-            </a:r>
-          </a:p>
-          <a:p>
-            <a:pPr lvl="1" fontAlgn="base">
-              <a:lnSpc>
-                <a:spcPct val="90000"/>
-              </a:lnSpc>
-            </a:pPr>
-            <a:r>
-              <a:rPr lang="en-US" sz="2000" dirty="0">
-                <a:solidFill>
-                  <a:srgbClr val="FFFFFF"/>
-                </a:solidFill>
-              </a:rPr>
-              <a:t>Any challenges or perspective changes- 5pts</a:t>
-            </a:r>
-          </a:p>
-          <a:p>
-            <a:pPr fontAlgn="base">
-              <a:lnSpc>
-                <a:spcPct val="90000"/>
-              </a:lnSpc>
-            </a:pPr>
-            <a:r>
-              <a:rPr lang="en-US" dirty="0">
-                <a:solidFill>
-                  <a:srgbClr val="FFFFFF"/>
-                </a:solidFill>
-              </a:rPr>
-              <a:t>Includes citations for research-10pts</a:t>
-            </a:r>
-          </a:p>
-          <a:p>
-            <a:pPr marL="0" indent="0">
-              <a:lnSpc>
-                <a:spcPct val="90000"/>
-              </a:lnSpc>
-            </a:pPr>
-            <a:endParaRPr lang="en-US" sz="700" dirty="0">
-              <a:solidFill>
-                <a:srgbClr val="FFFFFF"/>
-              </a:solidFill>
-            </a:endParaRPr>
-          </a:p>
-        </p:txBody>
-      </p:sp>
-      <p:sp>
-        <p:nvSpPr>
-          <p:cNvPr id="73" name="Freeform 31">
-            <a:extLst>
-              <a:ext uri="{FF2B5EF4-FFF2-40B4-BE49-F238E27FC236}">
-                <a16:creationId xmlns:a16="http://schemas.microsoft.com/office/drawing/2014/main" id="{81CC9B02-E087-4350-AEBD-2C3CF001AF01}"/>
-              </a:ext>
-              <a:ext uri="{C183D7F6-B498-43B3-948B-1728B52AA6E4}">
-                <adec:decorative xmlns:adec="http://schemas.microsoft.com/office/drawing/2017/decorative" val="1"/>
-              </a:ext>
-            </a:extLst>
-          </p:cNvPr>
-          <p:cNvSpPr>
-            <a:spLocks noGrp="1" noRot="1" noChangeAspect="1" noMove="1" noResize="1" noEditPoints="1" noAdjustHandles="1" noChangeArrowheads="1" noChangeShapeType="1" noTextEdit="1"/>
-          </p:cNvSpPr>
-          <p:nvPr>
-            <p:extLst>
-              <p:ext uri="{386F3935-93C4-4BCD-93E2-E3B085C9AB24}">
-                <p16:designElem xmlns:p16="http://schemas.microsoft.com/office/powerpoint/2015/main" val="1"/>
-              </p:ext>
-            </p:extLst>
-          </p:nvPr>
-        </p:nvSpPr>
-        <p:spPr>
-          <a:xfrm>
-            <a:off x="7015974" y="-1"/>
-            <a:ext cx="559472" cy="3709642"/>
-          </a:xfrm>
-          <a:custGeom>
-            <a:avLst/>
-            <a:gdLst>
-              <a:gd name="connsiteX0" fmla="*/ 0 w 559472"/>
-              <a:gd name="connsiteY0" fmla="*/ 0 h 3709642"/>
-              <a:gd name="connsiteX1" fmla="*/ 473952 w 559472"/>
-              <a:gd name="connsiteY1" fmla="*/ 0 h 3709642"/>
-              <a:gd name="connsiteX2" fmla="*/ 485840 w 559472"/>
-              <a:gd name="connsiteY2" fmla="*/ 161194 h 3709642"/>
-              <a:gd name="connsiteX3" fmla="*/ 523949 w 559472"/>
-              <a:gd name="connsiteY3" fmla="*/ 3672197 h 3709642"/>
-              <a:gd name="connsiteX4" fmla="*/ 454748 w 559472"/>
-              <a:gd name="connsiteY4" fmla="*/ 3709642 h 3709642"/>
-              <a:gd name="connsiteX5" fmla="*/ 448224 w 559472"/>
-              <a:gd name="connsiteY5" fmla="*/ 3510471 h 3709642"/>
-              <a:gd name="connsiteX6" fmla="*/ 443564 w 559472"/>
-              <a:gd name="connsiteY6" fmla="*/ 3408563 h 3709642"/>
-              <a:gd name="connsiteX7" fmla="*/ 438902 w 559472"/>
-              <a:gd name="connsiteY7" fmla="*/ 3304407 h 3709642"/>
-              <a:gd name="connsiteX8" fmla="*/ 433941 w 559472"/>
-              <a:gd name="connsiteY8" fmla="*/ 3198777 h 3709642"/>
-              <a:gd name="connsiteX9" fmla="*/ 427584 w 559472"/>
-              <a:gd name="connsiteY9" fmla="*/ 3092510 h 3709642"/>
-              <a:gd name="connsiteX10" fmla="*/ 420988 w 559472"/>
-              <a:gd name="connsiteY10" fmla="*/ 2984390 h 3709642"/>
-              <a:gd name="connsiteX11" fmla="*/ 414330 w 559472"/>
-              <a:gd name="connsiteY11" fmla="*/ 2874401 h 3709642"/>
-              <a:gd name="connsiteX12" fmla="*/ 406840 w 559472"/>
-              <a:gd name="connsiteY12" fmla="*/ 2762980 h 3709642"/>
-              <a:gd name="connsiteX13" fmla="*/ 397745 w 559472"/>
-              <a:gd name="connsiteY13" fmla="*/ 2650566 h 3709642"/>
-              <a:gd name="connsiteX14" fmla="*/ 389154 w 559472"/>
-              <a:gd name="connsiteY14" fmla="*/ 2536612 h 3709642"/>
-              <a:gd name="connsiteX15" fmla="*/ 379225 w 559472"/>
-              <a:gd name="connsiteY15" fmla="*/ 2421642 h 3709642"/>
-              <a:gd name="connsiteX16" fmla="*/ 368316 w 559472"/>
-              <a:gd name="connsiteY16" fmla="*/ 2305627 h 3709642"/>
-              <a:gd name="connsiteX17" fmla="*/ 357466 w 559472"/>
-              <a:gd name="connsiteY17" fmla="*/ 2189233 h 3709642"/>
-              <a:gd name="connsiteX18" fmla="*/ 344982 w 559472"/>
-              <a:gd name="connsiteY18" fmla="*/ 2071473 h 3709642"/>
-              <a:gd name="connsiteX19" fmla="*/ 332466 w 559472"/>
-              <a:gd name="connsiteY19" fmla="*/ 1952216 h 3709642"/>
-              <a:gd name="connsiteX20" fmla="*/ 319121 w 559472"/>
-              <a:gd name="connsiteY20" fmla="*/ 1833776 h 3709642"/>
-              <a:gd name="connsiteX21" fmla="*/ 304408 w 559472"/>
-              <a:gd name="connsiteY21" fmla="*/ 1713948 h 3709642"/>
-              <a:gd name="connsiteX22" fmla="*/ 288685 w 559472"/>
-              <a:gd name="connsiteY22" fmla="*/ 1592703 h 3709642"/>
-              <a:gd name="connsiteX23" fmla="*/ 273050 w 559472"/>
-              <a:gd name="connsiteY23" fmla="*/ 1471451 h 3709642"/>
-              <a:gd name="connsiteX24" fmla="*/ 255813 w 559472"/>
-              <a:gd name="connsiteY24" fmla="*/ 1350328 h 3709642"/>
-              <a:gd name="connsiteX25" fmla="*/ 237060 w 559472"/>
-              <a:gd name="connsiteY25" fmla="*/ 1227080 h 3709642"/>
-              <a:gd name="connsiteX26" fmla="*/ 218488 w 559472"/>
-              <a:gd name="connsiteY26" fmla="*/ 1106065 h 3709642"/>
-              <a:gd name="connsiteX27" fmla="*/ 198221 w 559472"/>
-              <a:gd name="connsiteY27" fmla="*/ 982940 h 3709642"/>
-              <a:gd name="connsiteX28" fmla="*/ 177152 w 559472"/>
-              <a:gd name="connsiteY28" fmla="*/ 858755 h 3709642"/>
-              <a:gd name="connsiteX29" fmla="*/ 155551 w 559472"/>
-              <a:gd name="connsiteY29" fmla="*/ 736861 h 3709642"/>
-              <a:gd name="connsiteX30" fmla="*/ 131782 w 559472"/>
-              <a:gd name="connsiteY30" fmla="*/ 613645 h 3709642"/>
-              <a:gd name="connsiteX31" fmla="*/ 107123 w 559472"/>
-              <a:gd name="connsiteY31" fmla="*/ 490500 h 3709642"/>
-              <a:gd name="connsiteX32" fmla="*/ 82552 w 559472"/>
-              <a:gd name="connsiteY32" fmla="*/ 367348 h 3709642"/>
-              <a:gd name="connsiteX33" fmla="*/ 55608 w 559472"/>
-              <a:gd name="connsiteY33" fmla="*/ 244762 h 3709642"/>
-              <a:gd name="connsiteX34" fmla="*/ 28130 w 559472"/>
-              <a:gd name="connsiteY34" fmla="*/ 122220 h 3709642"/>
-              <a:gd name="connsiteX35" fmla="*/ 0 w 559472"/>
-              <a:gd name="connsiteY35" fmla="*/ 0 h 3709642"/>
-            </a:gdLst>
-            <a:ahLst/>
-            <a:cxnLst>
-              <a:cxn ang="0">
-                <a:pos x="connsiteX0" y="connsiteY0"/>
-              </a:cxn>
-              <a:cxn ang="0">
-                <a:pos x="connsiteX1" y="connsiteY1"/>
-              </a:cxn>
-              <a:cxn ang="0">
-                <a:pos x="connsiteX2" y="connsiteY2"/>
-              </a:cxn>
-              <a:cxn ang="0">
-                <a:pos x="connsiteX3" y="connsiteY3"/>
-              </a:cxn>
-              <a:cxn ang="0">
-                <a:pos x="connsiteX4" y="connsiteY4"/>
-              </a:cxn>
-              <a:cxn ang="0">
-                <a:pos x="connsiteX5" y="connsiteY5"/>
-              </a:cxn>
-              <a:cxn ang="0">
-                <a:pos x="connsiteX6" y="connsiteY6"/>
-              </a:cxn>
-              <a:cxn ang="0">
-                <a:pos x="connsiteX7" y="connsiteY7"/>
-              </a:cxn>
-              <a:cxn ang="0">
-                <a:pos x="connsiteX8" y="connsiteY8"/>
-              </a:cxn>
-              <a:cxn ang="0">
-                <a:pos x="connsiteX9" y="connsiteY9"/>
-              </a:cxn>
-              <a:cxn ang="0">
-                <a:pos x="connsiteX10" y="connsiteY10"/>
-              </a:cxn>
-              <a:cxn ang="0">
-                <a:pos x="connsiteX11" y="connsiteY11"/>
-              </a:cxn>
-              <a:cxn ang="0">
-                <a:pos x="connsiteX12" y="connsiteY12"/>
-              </a:cxn>
-              <a:cxn ang="0">
-                <a:pos x="connsiteX13" y="connsiteY13"/>
-              </a:cxn>
-              <a:cxn ang="0">
-                <a:pos x="connsiteX14" y="connsiteY14"/>
-              </a:cxn>
-              <a:cxn ang="0">
-                <a:pos x="connsiteX15" y="connsiteY15"/>
-              </a:cxn>
-              <a:cxn ang="0">
-                <a:pos x="connsiteX16" y="connsiteY16"/>
-              </a:cxn>
-              <a:cxn ang="0">
-                <a:pos x="connsiteX17" y="connsiteY17"/>
-              </a:cxn>
-              <a:cxn ang="0">
-                <a:pos x="connsiteX18" y="connsiteY18"/>
-              </a:cxn>
-              <a:cxn ang="0">
-                <a:pos x="connsiteX19" y="connsiteY19"/>
-              </a:cxn>
-              <a:cxn ang="0">
-                <a:pos x="connsiteX20" y="connsiteY20"/>
-              </a:cxn>
-              <a:cxn ang="0">
-                <a:pos x="connsiteX21" y="connsiteY21"/>
-              </a:cxn>
-              <a:cxn ang="0">
-                <a:pos x="connsiteX22" y="connsiteY22"/>
-              </a:cxn>
-              <a:cxn ang="0">
-                <a:pos x="connsiteX23" y="connsiteY23"/>
-              </a:cxn>
-              <a:cxn ang="0">
-                <a:pos x="connsiteX24" y="connsiteY24"/>
-              </a:cxn>
-              <a:cxn ang="0">
-                <a:pos x="connsiteX25" y="connsiteY25"/>
-              </a:cxn>
-              <a:cxn ang="0">
-                <a:pos x="connsiteX26" y="connsiteY26"/>
-              </a:cxn>
-              <a:cxn ang="0">
-                <a:pos x="connsiteX27" y="connsiteY27"/>
-              </a:cxn>
-              <a:cxn ang="0">
-                <a:pos x="connsiteX28" y="connsiteY28"/>
-              </a:cxn>
-              <a:cxn ang="0">
-                <a:pos x="connsiteX29" y="connsiteY29"/>
-              </a:cxn>
-              <a:cxn ang="0">
-                <a:pos x="connsiteX30" y="connsiteY30"/>
-              </a:cxn>
-              <a:cxn ang="0">
-                <a:pos x="connsiteX31" y="connsiteY31"/>
-              </a:cxn>
-              <a:cxn ang="0">
-                <a:pos x="connsiteX32" y="connsiteY32"/>
-              </a:cxn>
-              <a:cxn ang="0">
-                <a:pos x="connsiteX33" y="connsiteY33"/>
-              </a:cxn>
-              <a:cxn ang="0">
-                <a:pos x="connsiteX34" y="connsiteY34"/>
-              </a:cxn>
-              <a:cxn ang="0">
-                <a:pos x="connsiteX35" y="connsiteY35"/>
-              </a:cxn>
-            </a:cxnLst>
-            <a:rect l="l" t="t" r="r" b="b"/>
-            <a:pathLst>
-              <a:path w="559472" h="3709642">
-                <a:moveTo>
-                  <a:pt x="0" y="0"/>
-                </a:moveTo>
-                <a:lnTo>
-                  <a:pt x="473952" y="0"/>
-                </a:lnTo>
-                <a:lnTo>
-                  <a:pt x="485840" y="161194"/>
-                </a:lnTo>
-                <a:cubicBezTo>
-                  <a:pt x="552063" y="1147770"/>
-                  <a:pt x="592441" y="3086737"/>
-                  <a:pt x="523949" y="3672197"/>
-                </a:cubicBezTo>
-                <a:cubicBezTo>
-                  <a:pt x="500842" y="3684557"/>
-                  <a:pt x="477855" y="3697282"/>
-                  <a:pt x="454748" y="3709642"/>
-                </a:cubicBezTo>
-                <a:lnTo>
-                  <a:pt x="448224" y="3510471"/>
-                </a:lnTo>
-                <a:lnTo>
-                  <a:pt x="443564" y="3408563"/>
-                </a:lnTo>
-                <a:lnTo>
-                  <a:pt x="438902" y="3304407"/>
-                </a:lnTo>
-                <a:lnTo>
-                  <a:pt x="433941" y="3198777"/>
-                </a:lnTo>
-                <a:lnTo>
-                  <a:pt x="427584" y="3092510"/>
-                </a:lnTo>
-                <a:lnTo>
-                  <a:pt x="420988" y="2984390"/>
-                </a:lnTo>
-                <a:lnTo>
-                  <a:pt x="414330" y="2874401"/>
-                </a:lnTo>
-                <a:lnTo>
-                  <a:pt x="406840" y="2762980"/>
-                </a:lnTo>
-                <a:lnTo>
-                  <a:pt x="397745" y="2650566"/>
-                </a:lnTo>
-                <a:lnTo>
-                  <a:pt x="389154" y="2536612"/>
-                </a:lnTo>
-                <a:lnTo>
-                  <a:pt x="379225" y="2421642"/>
-                </a:lnTo>
-                <a:lnTo>
-                  <a:pt x="368316" y="2305627"/>
-                </a:lnTo>
-                <a:lnTo>
-                  <a:pt x="357466" y="2189233"/>
-                </a:lnTo>
-                <a:lnTo>
-                  <a:pt x="344982" y="2071473"/>
-                </a:lnTo>
-                <a:lnTo>
-                  <a:pt x="332466" y="1952216"/>
-                </a:lnTo>
-                <a:lnTo>
-                  <a:pt x="319121" y="1833776"/>
-                </a:lnTo>
-                <a:lnTo>
-                  <a:pt x="304408" y="1713948"/>
-                </a:lnTo>
-                <a:lnTo>
-                  <a:pt x="288685" y="1592703"/>
-                </a:lnTo>
-                <a:lnTo>
-                  <a:pt x="273050" y="1471451"/>
-                </a:lnTo>
-                <a:lnTo>
-                  <a:pt x="255813" y="1350328"/>
-                </a:lnTo>
-                <a:lnTo>
-                  <a:pt x="237060" y="1227080"/>
-                </a:lnTo>
-                <a:lnTo>
-                  <a:pt x="218488" y="1106065"/>
-                </a:lnTo>
-                <a:lnTo>
-                  <a:pt x="198221" y="982940"/>
-                </a:lnTo>
-                <a:lnTo>
-                  <a:pt x="177152" y="858755"/>
-                </a:lnTo>
-                <a:lnTo>
-                  <a:pt x="155551" y="736861"/>
-                </a:lnTo>
-                <a:lnTo>
-                  <a:pt x="131782" y="613645"/>
-                </a:lnTo>
-                <a:lnTo>
-                  <a:pt x="107123" y="490500"/>
-                </a:lnTo>
-                <a:lnTo>
-                  <a:pt x="82552" y="367348"/>
-                </a:lnTo>
-                <a:lnTo>
-                  <a:pt x="55608" y="244762"/>
-                </a:lnTo>
-                <a:lnTo>
-                  <a:pt x="28130" y="122220"/>
-                </a:lnTo>
-                <a:lnTo>
-                  <a:pt x="0" y="0"/>
-                </a:lnTo>
-                <a:close/>
-              </a:path>
-            </a:pathLst>
-          </a:custGeom>
-          <a:solidFill>
-            <a:schemeClr val="tx1">
-              <a:alpha val="20000"/>
-            </a:schemeClr>
-          </a:solidFill>
-          <a:ln>
-            <a:noFill/>
-          </a:ln>
-        </p:spPr>
-        <p:txBody>
-          <a:bodyPr rtlCol="0" anchor="ctr"/>
-          <a:lstStyle/>
-          <a:p>
-            <a:pPr algn="ctr"/>
-            <a:endParaRPr lang="en-US"/>
-          </a:p>
-        </p:txBody>
-      </p:sp>
-      <p:pic>
-        <p:nvPicPr>
-          <p:cNvPr id="10" name="Picture Placeholder 9">
-            <a:extLst>
-              <a:ext uri="{FF2B5EF4-FFF2-40B4-BE49-F238E27FC236}">
-                <a16:creationId xmlns:a16="http://schemas.microsoft.com/office/drawing/2014/main" id="{2586F44D-39C7-121F-EE4A-48EB3D47952C}"/>
-              </a:ext>
-            </a:extLst>
-          </p:cNvPr>
-          <p:cNvPicPr>
-            <a:picLocks noGrp="1" noChangeAspect="1"/>
-          </p:cNvPicPr>
-          <p:nvPr>
-            <p:ph type="pic" sz="quarter" idx="15"/>
-          </p:nvPr>
-        </p:nvPicPr>
-        <p:blipFill>
-          <a:blip r:embed="rId7">
-            <a:extLst>
-              <a:ext uri="{28A0092B-C50C-407E-A947-70E740481C1C}">
-                <a14:useLocalDpi xmlns:a14="http://schemas.microsoft.com/office/drawing/2010/main" val="0"/>
-              </a:ext>
-            </a:extLst>
-          </a:blip>
-          <a:srcRect l="12134" r="15494" b="-1"/>
-          <a:stretch>
-            <a:fillRect/>
-          </a:stretch>
-        </p:blipFill>
-        <p:spPr>
-          <a:xfrm>
-            <a:off x="7229175" y="1"/>
-            <a:ext cx="4963245" cy="6858001"/>
-          </a:xfrm>
-          <a:custGeom>
-            <a:avLst/>
-            <a:gdLst/>
-            <a:ahLst/>
-            <a:cxnLst/>
-            <a:rect l="l" t="t" r="r" b="b"/>
-            <a:pathLst>
-              <a:path w="4963245" h="6858001">
-                <a:moveTo>
-                  <a:pt x="1177" y="0"/>
-                </a:moveTo>
-                <a:lnTo>
-                  <a:pt x="1344715" y="0"/>
-                </a:lnTo>
-                <a:lnTo>
-                  <a:pt x="1344715" y="1"/>
-                </a:lnTo>
-                <a:lnTo>
-                  <a:pt x="4963245" y="1"/>
-                </a:lnTo>
-                <a:lnTo>
-                  <a:pt x="4963244" y="6858001"/>
-                </a:lnTo>
-                <a:lnTo>
-                  <a:pt x="900697" y="6858001"/>
-                </a:lnTo>
-                <a:lnTo>
-                  <a:pt x="900697" y="6858000"/>
-                </a:lnTo>
-                <a:lnTo>
-                  <a:pt x="0" y="6858000"/>
-                </a:lnTo>
-                <a:lnTo>
-                  <a:pt x="5883" y="6817538"/>
-                </a:lnTo>
-                <a:lnTo>
-                  <a:pt x="23196" y="6698894"/>
-                </a:lnTo>
-                <a:lnTo>
-                  <a:pt x="35299" y="6612483"/>
-                </a:lnTo>
-                <a:lnTo>
-                  <a:pt x="48073" y="6509613"/>
-                </a:lnTo>
-                <a:lnTo>
-                  <a:pt x="63369" y="6387541"/>
-                </a:lnTo>
-                <a:lnTo>
-                  <a:pt x="79506" y="6252438"/>
-                </a:lnTo>
-                <a:lnTo>
-                  <a:pt x="96483" y="6100191"/>
-                </a:lnTo>
-                <a:lnTo>
-                  <a:pt x="114469" y="5934227"/>
-                </a:lnTo>
-                <a:lnTo>
-                  <a:pt x="132454" y="5753862"/>
-                </a:lnTo>
-                <a:lnTo>
-                  <a:pt x="150776" y="5561838"/>
-                </a:lnTo>
-                <a:lnTo>
-                  <a:pt x="167753" y="5354726"/>
-                </a:lnTo>
-                <a:lnTo>
-                  <a:pt x="184058" y="5138013"/>
-                </a:lnTo>
-                <a:lnTo>
-                  <a:pt x="198849" y="4908956"/>
-                </a:lnTo>
-                <a:lnTo>
-                  <a:pt x="212969" y="4670298"/>
-                </a:lnTo>
-                <a:lnTo>
-                  <a:pt x="226248" y="4421352"/>
-                </a:lnTo>
-                <a:lnTo>
-                  <a:pt x="230955" y="4293793"/>
-                </a:lnTo>
-                <a:lnTo>
-                  <a:pt x="236165" y="4163492"/>
-                </a:lnTo>
-                <a:lnTo>
-                  <a:pt x="241040" y="4031133"/>
-                </a:lnTo>
-                <a:lnTo>
-                  <a:pt x="244234" y="3898087"/>
-                </a:lnTo>
-                <a:lnTo>
-                  <a:pt x="247091" y="3762299"/>
-                </a:lnTo>
-                <a:lnTo>
-                  <a:pt x="250117" y="3625139"/>
-                </a:lnTo>
-                <a:lnTo>
-                  <a:pt x="252134" y="3485236"/>
-                </a:lnTo>
-                <a:lnTo>
-                  <a:pt x="252134" y="3343961"/>
-                </a:lnTo>
-                <a:lnTo>
-                  <a:pt x="253142" y="3201315"/>
-                </a:lnTo>
-                <a:lnTo>
-                  <a:pt x="252134" y="3057297"/>
-                </a:lnTo>
-                <a:lnTo>
-                  <a:pt x="250117" y="2911221"/>
-                </a:lnTo>
-                <a:lnTo>
-                  <a:pt x="248268" y="2765146"/>
-                </a:lnTo>
-                <a:lnTo>
-                  <a:pt x="244234" y="2617013"/>
-                </a:lnTo>
-                <a:lnTo>
-                  <a:pt x="240032" y="2467509"/>
-                </a:lnTo>
-                <a:lnTo>
-                  <a:pt x="235157" y="2318004"/>
-                </a:lnTo>
-                <a:lnTo>
-                  <a:pt x="228266" y="2167128"/>
-                </a:lnTo>
-                <a:lnTo>
-                  <a:pt x="220029" y="2014881"/>
-                </a:lnTo>
-                <a:lnTo>
-                  <a:pt x="212129" y="1861947"/>
-                </a:lnTo>
-                <a:lnTo>
-                  <a:pt x="202044" y="1709014"/>
-                </a:lnTo>
-                <a:lnTo>
-                  <a:pt x="189941" y="1554023"/>
-                </a:lnTo>
-                <a:lnTo>
-                  <a:pt x="177839" y="1401090"/>
-                </a:lnTo>
-                <a:lnTo>
-                  <a:pt x="163887" y="1245413"/>
-                </a:lnTo>
-                <a:lnTo>
-                  <a:pt x="148591" y="1089051"/>
-                </a:lnTo>
-                <a:lnTo>
-                  <a:pt x="132455" y="934746"/>
-                </a:lnTo>
-                <a:lnTo>
-                  <a:pt x="113629" y="778383"/>
-                </a:lnTo>
-                <a:lnTo>
-                  <a:pt x="93458" y="622707"/>
-                </a:lnTo>
-                <a:lnTo>
-                  <a:pt x="73455" y="466344"/>
-                </a:lnTo>
-                <a:lnTo>
-                  <a:pt x="50091" y="310668"/>
-                </a:lnTo>
-                <a:lnTo>
-                  <a:pt x="26222" y="155677"/>
-                </a:lnTo>
-                <a:close/>
-              </a:path>
-            </a:pathLst>
-          </a:custGeom>
-          <a:blipFill dpi="0" rotWithShape="1">
-            <a:blip r:embed="rId8" cstate="screen">
-              <a:alphaModFix amt="60000"/>
-              <a:extLst>
-                <a:ext uri="{28A0092B-C50C-407E-A947-70E740481C1C}">
-                  <a14:useLocalDpi xmlns:a14="http://schemas.microsoft.com/office/drawing/2010/main"/>
-                </a:ext>
-              </a:extLst>
-            </a:blip>
-            <a:srcRect/>
-            <a:stretch>
-              <a:fillRect/>
-            </a:stretch>
-          </a:blipFill>
-        </p:spPr>
-      </p:pic>
-    </p:spTree>
-    <p:extLst>
-      <p:ext uri="{BB962C8B-B14F-4D97-AF65-F5344CB8AC3E}">
-        <p14:creationId xmlns:p14="http://schemas.microsoft.com/office/powerpoint/2010/main" val="599029612"/>
-      </p:ext>
-    </p:extLst>
-  </p:cSld>
-  <p:clrMapOvr>
-    <a:masterClrMapping/>
-  </p:clrMapOvr>
-</p:sld>
-</file>
-
-<file path=ppt/slides/slide8.xml><?xml version="1.0" encoding="utf-8"?>
-<p:sld xmlns:a="http://schemas.openxmlformats.org/drawingml/2006/main" xmlns:r="http://schemas.openxmlformats.org/officeDocument/2006/relationships" xmlns:p="http://schemas.openxmlformats.org/presentationml/2006/main">
-  <p:cSld>
-    <p:spTree>
-      <p:nvGrpSpPr>
-        <p:cNvPr id="1" name=""/>
-        <p:cNvGrpSpPr/>
-        <p:nvPr/>
-      </p:nvGrpSpPr>
-      <p:grpSpPr>
-        <a:xfrm>
-          <a:off x="0" y="0"/>
-          <a:ext cx="0" cy="0"/>
-          <a:chOff x="0" y="0"/>
-          <a:chExt cx="0" cy="0"/>
-        </a:xfrm>
-      </p:grpSpPr>
-      <p:sp>
-        <p:nvSpPr>
-          <p:cNvPr id="2" name="Title 1">
-            <a:extLst>
-              <a:ext uri="{FF2B5EF4-FFF2-40B4-BE49-F238E27FC236}">
-                <a16:creationId xmlns:a16="http://schemas.microsoft.com/office/drawing/2014/main" id="{324C32F8-E21D-68DC-2A6B-6A44F01175C0}"/>
-              </a:ext>
-            </a:extLst>
-          </p:cNvPr>
-          <p:cNvSpPr>
-            <a:spLocks noGrp="1"/>
-          </p:cNvSpPr>
-          <p:nvPr>
-            <p:ph type="title"/>
-          </p:nvPr>
-        </p:nvSpPr>
-        <p:spPr>
-          <a:xfrm>
-            <a:off x="623342" y="777348"/>
-            <a:ext cx="10945316" cy="746761"/>
-          </a:xfrm>
-        </p:spPr>
-        <p:txBody>
-          <a:bodyPr/>
-          <a:lstStyle/>
-          <a:p>
-            <a:r>
-              <a:rPr lang="en-US" dirty="0"/>
-              <a:t>AI Integration</a:t>
-            </a:r>
-          </a:p>
-        </p:txBody>
-      </p:sp>
-      <p:sp>
-        <p:nvSpPr>
-          <p:cNvPr id="3" name="Text Placeholder 2">
-            <a:extLst>
-              <a:ext uri="{FF2B5EF4-FFF2-40B4-BE49-F238E27FC236}">
-                <a16:creationId xmlns:a16="http://schemas.microsoft.com/office/drawing/2014/main" id="{E435B5EE-EC32-8941-B9F3-74604A298061}"/>
-              </a:ext>
-            </a:extLst>
-          </p:cNvPr>
-          <p:cNvSpPr>
-            <a:spLocks noGrp="1"/>
-          </p:cNvSpPr>
-          <p:nvPr>
-            <p:ph type="body" sz="quarter" idx="13"/>
-          </p:nvPr>
-        </p:nvSpPr>
-        <p:spPr>
-          <a:xfrm>
-            <a:off x="623342" y="1705113"/>
-            <a:ext cx="10609358" cy="4471752"/>
-          </a:xfrm>
-        </p:spPr>
-        <p:txBody>
-          <a:bodyPr vert="horz" lIns="91440" tIns="45720" rIns="91440" bIns="45720" rtlCol="0" anchor="t">
-            <a:normAutofit fontScale="85000" lnSpcReduction="20000"/>
-          </a:bodyPr>
-          <a:lstStyle/>
-          <a:p>
-            <a:pPr marL="0" indent="0">
-              <a:buNone/>
-            </a:pPr>
-            <a:r>
-              <a:rPr lang="en-US" dirty="0"/>
-              <a:t>Disclose any AI software that you used in the citations section of the reflection and explain for what purpose. </a:t>
-            </a:r>
-            <a:endParaRPr lang="en-US" b="1" dirty="0"/>
-          </a:p>
-          <a:p>
-            <a:pPr marL="0" indent="0">
-              <a:buNone/>
-            </a:pPr>
-            <a:r>
-              <a:rPr lang="en-US" b="1" dirty="0"/>
-              <a:t>Acceptable Uses:</a:t>
-            </a:r>
-            <a:endParaRPr lang="en-US" dirty="0"/>
-          </a:p>
-          <a:p>
-            <a:r>
-              <a:rPr lang="en-US" dirty="0"/>
-              <a:t>Brainstorming</a:t>
-            </a:r>
-          </a:p>
-          <a:p>
-            <a:r>
-              <a:rPr lang="en-US" dirty="0"/>
-              <a:t>Clarifying concepts, terms, or historical/cultural context encountered during research</a:t>
-            </a:r>
-          </a:p>
-          <a:p>
-            <a:r>
-              <a:rPr lang="en-US" dirty="0"/>
-              <a:t>Checking grammar, spelling, and citation formatting in the final presentation and reflection</a:t>
-            </a:r>
-          </a:p>
-          <a:p>
-            <a:r>
-              <a:rPr lang="en-US" dirty="0"/>
-              <a:t>Organizing the layout for the presentation</a:t>
-            </a:r>
-          </a:p>
-          <a:p>
-            <a:pPr marL="0" indent="0">
-              <a:buNone/>
-            </a:pPr>
-            <a:r>
-              <a:rPr lang="en-US" b="1" dirty="0"/>
-              <a:t>Non-Acceptable Uses</a:t>
-            </a:r>
-          </a:p>
-          <a:p>
-            <a:r>
-              <a:rPr lang="en-US" dirty="0"/>
-              <a:t>AI should</a:t>
-            </a:r>
-            <a:r>
-              <a:rPr lang="en-US" b="1" dirty="0"/>
-              <a:t> not</a:t>
-            </a:r>
-            <a:r>
-              <a:rPr lang="en-US" dirty="0"/>
-              <a:t> be used in choosing your presentation piece. You should choose a piece that is already relevant or interesting to you.</a:t>
-            </a:r>
-          </a:p>
-          <a:p>
-            <a:pPr lvl="1"/>
-            <a:r>
-              <a:rPr lang="en-US" dirty="0"/>
-              <a:t>Why? This will make the reflection section easier to complete when you have a connection to the material. </a:t>
-            </a:r>
-          </a:p>
-          <a:p>
-            <a:r>
-              <a:rPr lang="en-US" dirty="0"/>
-              <a:t>Using AI as a substitute for reading or viewing sources.</a:t>
-            </a:r>
-          </a:p>
-          <a:p>
-            <a:pPr lvl="1"/>
-            <a:r>
-              <a:rPr lang="en-US" dirty="0"/>
-              <a:t>You are responsible for any misrepresented, misquoted, or false information presented.</a:t>
-            </a:r>
-          </a:p>
-          <a:p>
-            <a:r>
-              <a:rPr lang="en-US" dirty="0"/>
-              <a:t>Completing the reflection showcases your own perspective and process with this assignment.</a:t>
-            </a:r>
-          </a:p>
-          <a:p>
-            <a:pPr lvl="1"/>
-            <a:r>
-              <a:rPr lang="en-US" dirty="0"/>
-              <a:t>If an AI grammar or spelling checker is used for the reflection, include the original and rewritten piece.</a:t>
-            </a:r>
-          </a:p>
-          <a:p>
-            <a:endParaRPr lang="en-US" dirty="0"/>
-          </a:p>
-        </p:txBody>
-      </p:sp>
-    </p:spTree>
-    <p:extLst>
-      <p:ext uri="{BB962C8B-B14F-4D97-AF65-F5344CB8AC3E}">
-        <p14:creationId xmlns:p14="http://schemas.microsoft.com/office/powerpoint/2010/main" val="2168735708"/>
       </p:ext>
     </p:extLst>
   </p:cSld>

</xml_diff>